<commit_message>
chore : update pptfile format
</commit_message>
<xml_diff>
--- a/clink/Template/NewPptFile.pptx
+++ b/clink/Template/NewPptFile.pptx
@@ -4,9 +4,6 @@
   <p:sldMasterIdLst>
     <p:sldMasterId id="2147483648" r:id="rId1"/>
   </p:sldMasterIdLst>
-  <p:notesMasterIdLst>
-    <p:notesMasterId r:id="rId3"/>
-  </p:notesMasterIdLst>
   <p:sldIdLst>
     <p:sldId id="256" r:id="rId2"/>
   </p:sldIdLst>
@@ -111,444 +108,8 @@
     <p:ext uri="{EFAFB233-063F-42B5-8137-9DF3F51BA10A}">
       <p15:sldGuideLst xmlns:p15="http://schemas.microsoft.com/office/powerpoint/2012/main"/>
     </p:ext>
-    <p:ext uri="{2D200454-40CA-4A62-9FC3-DE9A4176ACB9}">
-      <p15:notesGuideLst xmlns:p15="http://schemas.microsoft.com/office/powerpoint/2012/main"/>
-    </p:ext>
   </p:extLst>
 </p:presentation>
-</file>
-
-<file path=ppt/notesMasters/notesMaster1.xml><?xml version="1.0" encoding="utf-8"?>
-<p:notesMaster xmlns:a="http://schemas.openxmlformats.org/drawingml/2006/main" xmlns:r="http://schemas.openxmlformats.org/officeDocument/2006/relationships" xmlns:p="http://schemas.openxmlformats.org/presentationml/2006/main">
-  <p:cSld>
-    <p:bg>
-      <p:bgRef idx="1001">
-        <a:schemeClr val="bg1"/>
-      </p:bgRef>
-    </p:bg>
-    <p:spTree>
-      <p:nvGrpSpPr>
-        <p:cNvPr id="1" name=""/>
-        <p:cNvGrpSpPr/>
-        <p:nvPr/>
-      </p:nvGrpSpPr>
-      <p:grpSpPr>
-        <a:xfrm>
-          <a:off x="0" y="0"/>
-          <a:ext cx="0" cy="0"/>
-          <a:chOff x="0" y="0"/>
-          <a:chExt cx="0" cy="0"/>
-        </a:xfrm>
-      </p:grpSpPr>
-      <p:sp>
-        <p:nvSpPr>
-          <p:cNvPr id="2" name="머리글 개체 틀 1"/>
-          <p:cNvSpPr>
-            <a:spLocks noGrp="1"/>
-          </p:cNvSpPr>
-          <p:nvPr>
-            <p:ph type="hdr" sz="quarter"/>
-          </p:nvPr>
-        </p:nvSpPr>
-        <p:spPr>
-          <a:xfrm>
-            <a:off x="0" y="0"/>
-            <a:ext cx="2971800" cy="458788"/>
-          </a:xfrm>
-          <a:prstGeom prst="rect">
-            <a:avLst/>
-          </a:prstGeom>
-        </p:spPr>
-        <p:txBody>
-          <a:bodyPr vert="horz" lIns="91440" tIns="45720" rIns="91440" bIns="45720" rtlCol="0"/>
-          <a:lstStyle>
-            <a:lvl1pPr algn="l">
-              <a:defRPr sz="1200"/>
-            </a:lvl1pPr>
-          </a:lstStyle>
-          <a:p>
-            <a:endParaRPr lang="ko-KR" altLang="en-US"/>
-          </a:p>
-        </p:txBody>
-      </p:sp>
-      <p:sp>
-        <p:nvSpPr>
-          <p:cNvPr id="3" name="날짜 개체 틀 2"/>
-          <p:cNvSpPr>
-            <a:spLocks noGrp="1"/>
-          </p:cNvSpPr>
-          <p:nvPr>
-            <p:ph type="dt" idx="1"/>
-          </p:nvPr>
-        </p:nvSpPr>
-        <p:spPr>
-          <a:xfrm>
-            <a:off x="3884613" y="0"/>
-            <a:ext cx="2971800" cy="458788"/>
-          </a:xfrm>
-          <a:prstGeom prst="rect">
-            <a:avLst/>
-          </a:prstGeom>
-        </p:spPr>
-        <p:txBody>
-          <a:bodyPr vert="horz" lIns="91440" tIns="45720" rIns="91440" bIns="45720" rtlCol="0"/>
-          <a:lstStyle>
-            <a:lvl1pPr algn="r">
-              <a:defRPr sz="1200"/>
-            </a:lvl1pPr>
-          </a:lstStyle>
-          <a:p>
-            <a:fld id="{49DA2D17-2E6F-41CA-ABE2-E5D705B5D76C}" type="datetimeFigureOut">
-              <a:rPr lang="ko-KR" altLang="en-US" smtClean="0"/>
-              <a:t>2025-11-29 Sat</a:t>
-            </a:fld>
-            <a:endParaRPr lang="ko-KR" altLang="en-US"/>
-          </a:p>
-        </p:txBody>
-      </p:sp>
-      <p:sp>
-        <p:nvSpPr>
-          <p:cNvPr id="4" name="슬라이드 이미지 개체 틀 3"/>
-          <p:cNvSpPr>
-            <a:spLocks noGrp="1" noRot="1" noChangeAspect="1"/>
-          </p:cNvSpPr>
-          <p:nvPr>
-            <p:ph type="sldImg" idx="2"/>
-          </p:nvPr>
-        </p:nvSpPr>
-        <p:spPr>
-          <a:xfrm>
-            <a:off x="685800" y="1143000"/>
-            <a:ext cx="5486400" cy="3086100"/>
-          </a:xfrm>
-          <a:prstGeom prst="rect">
-            <a:avLst/>
-          </a:prstGeom>
-          <a:noFill/>
-          <a:ln w="12700">
-            <a:solidFill>
-              <a:prstClr val="black"/>
-            </a:solidFill>
-          </a:ln>
-        </p:spPr>
-        <p:txBody>
-          <a:bodyPr vert="horz" lIns="91440" tIns="45720" rIns="91440" bIns="45720" rtlCol="0" anchor="ctr"/>
-          <a:lstStyle/>
-          <a:p>
-            <a:endParaRPr lang="ko-KR" altLang="en-US"/>
-          </a:p>
-        </p:txBody>
-      </p:sp>
-      <p:sp>
-        <p:nvSpPr>
-          <p:cNvPr id="5" name="슬라이드 노트 개체 틀 4"/>
-          <p:cNvSpPr>
-            <a:spLocks noGrp="1"/>
-          </p:cNvSpPr>
-          <p:nvPr>
-            <p:ph type="body" sz="quarter" idx="3"/>
-          </p:nvPr>
-        </p:nvSpPr>
-        <p:spPr>
-          <a:xfrm>
-            <a:off x="685800" y="4400550"/>
-            <a:ext cx="5486400" cy="3600450"/>
-          </a:xfrm>
-          <a:prstGeom prst="rect">
-            <a:avLst/>
-          </a:prstGeom>
-        </p:spPr>
-        <p:txBody>
-          <a:bodyPr vert="horz" lIns="91440" tIns="45720" rIns="91440" bIns="45720" rtlCol="0"/>
-          <a:lstStyle/>
-          <a:p>
-            <a:pPr lvl="0"/>
-            <a:r>
-              <a:rPr lang="ko-KR" altLang="en-US"/>
-              <a:t>마스터 텍스트 스타일을 편집하려면 클릭</a:t>
-            </a:r>
-          </a:p>
-          <a:p>
-            <a:pPr lvl="1"/>
-            <a:r>
-              <a:rPr lang="ko-KR" altLang="en-US"/>
-              <a:t>두 번째 수준</a:t>
-            </a:r>
-          </a:p>
-          <a:p>
-            <a:pPr lvl="2"/>
-            <a:r>
-              <a:rPr lang="ko-KR" altLang="en-US"/>
-              <a:t>세 번째 수준</a:t>
-            </a:r>
-          </a:p>
-          <a:p>
-            <a:pPr lvl="3"/>
-            <a:r>
-              <a:rPr lang="ko-KR" altLang="en-US"/>
-              <a:t>네 번째 수준</a:t>
-            </a:r>
-          </a:p>
-          <a:p>
-            <a:pPr lvl="4"/>
-            <a:r>
-              <a:rPr lang="ko-KR" altLang="en-US"/>
-              <a:t>다섯 번째 수준</a:t>
-            </a:r>
-          </a:p>
-        </p:txBody>
-      </p:sp>
-      <p:sp>
-        <p:nvSpPr>
-          <p:cNvPr id="6" name="바닥글 개체 틀 5"/>
-          <p:cNvSpPr>
-            <a:spLocks noGrp="1"/>
-          </p:cNvSpPr>
-          <p:nvPr>
-            <p:ph type="ftr" sz="quarter" idx="4"/>
-          </p:nvPr>
-        </p:nvSpPr>
-        <p:spPr>
-          <a:xfrm>
-            <a:off x="0" y="8685213"/>
-            <a:ext cx="2971800" cy="458787"/>
-          </a:xfrm>
-          <a:prstGeom prst="rect">
-            <a:avLst/>
-          </a:prstGeom>
-        </p:spPr>
-        <p:txBody>
-          <a:bodyPr vert="horz" lIns="91440" tIns="45720" rIns="91440" bIns="45720" rtlCol="0" anchor="b"/>
-          <a:lstStyle>
-            <a:lvl1pPr algn="l">
-              <a:defRPr sz="1200"/>
-            </a:lvl1pPr>
-          </a:lstStyle>
-          <a:p>
-            <a:endParaRPr lang="ko-KR" altLang="en-US"/>
-          </a:p>
-        </p:txBody>
-      </p:sp>
-      <p:sp>
-        <p:nvSpPr>
-          <p:cNvPr id="7" name="슬라이드 번호 개체 틀 6"/>
-          <p:cNvSpPr>
-            <a:spLocks noGrp="1"/>
-          </p:cNvSpPr>
-          <p:nvPr>
-            <p:ph type="sldNum" sz="quarter" idx="5"/>
-          </p:nvPr>
-        </p:nvSpPr>
-        <p:spPr>
-          <a:xfrm>
-            <a:off x="3884613" y="8685213"/>
-            <a:ext cx="2971800" cy="458787"/>
-          </a:xfrm>
-          <a:prstGeom prst="rect">
-            <a:avLst/>
-          </a:prstGeom>
-        </p:spPr>
-        <p:txBody>
-          <a:bodyPr vert="horz" lIns="91440" tIns="45720" rIns="91440" bIns="45720" rtlCol="0" anchor="b"/>
-          <a:lstStyle>
-            <a:lvl1pPr algn="r">
-              <a:defRPr sz="1200"/>
-            </a:lvl1pPr>
-          </a:lstStyle>
-          <a:p>
-            <a:fld id="{3DB8E99A-A821-4878-BB7E-B74749CD0689}" type="slidenum">
-              <a:rPr lang="ko-KR" altLang="en-US" smtClean="0"/>
-              <a:t>‹#›</a:t>
-            </a:fld>
-            <a:endParaRPr lang="ko-KR" altLang="en-US"/>
-          </a:p>
-        </p:txBody>
-      </p:sp>
-    </p:spTree>
-    <p:extLst>
-      <p:ext uri="{BB962C8B-B14F-4D97-AF65-F5344CB8AC3E}">
-        <p14:creationId xmlns:p14="http://schemas.microsoft.com/office/powerpoint/2010/main" val="840004818"/>
-      </p:ext>
-    </p:extLst>
-  </p:cSld>
-  <p:clrMap bg1="lt1" tx1="dk1" bg2="lt2" tx2="dk2" accent1="accent1" accent2="accent2" accent3="accent3" accent4="accent4" accent5="accent5" accent6="accent6" hlink="hlink" folHlink="folHlink"/>
-  <p:notesStyle>
-    <a:lvl1pPr marL="0" algn="l" defTabSz="914400" rtl="0" eaLnBrk="1" latinLnBrk="1" hangingPunct="1">
-      <a:defRPr sz="1200" kern="1200">
-        <a:solidFill>
-          <a:schemeClr val="tx1"/>
-        </a:solidFill>
-        <a:latin typeface="+mn-lt"/>
-        <a:ea typeface="+mn-ea"/>
-        <a:cs typeface="+mn-cs"/>
-      </a:defRPr>
-    </a:lvl1pPr>
-    <a:lvl2pPr marL="457200" algn="l" defTabSz="914400" rtl="0" eaLnBrk="1" latinLnBrk="1" hangingPunct="1">
-      <a:defRPr sz="1200" kern="1200">
-        <a:solidFill>
-          <a:schemeClr val="tx1"/>
-        </a:solidFill>
-        <a:latin typeface="+mn-lt"/>
-        <a:ea typeface="+mn-ea"/>
-        <a:cs typeface="+mn-cs"/>
-      </a:defRPr>
-    </a:lvl2pPr>
-    <a:lvl3pPr marL="914400" algn="l" defTabSz="914400" rtl="0" eaLnBrk="1" latinLnBrk="1" hangingPunct="1">
-      <a:defRPr sz="1200" kern="1200">
-        <a:solidFill>
-          <a:schemeClr val="tx1"/>
-        </a:solidFill>
-        <a:latin typeface="+mn-lt"/>
-        <a:ea typeface="+mn-ea"/>
-        <a:cs typeface="+mn-cs"/>
-      </a:defRPr>
-    </a:lvl3pPr>
-    <a:lvl4pPr marL="1371600" algn="l" defTabSz="914400" rtl="0" eaLnBrk="1" latinLnBrk="1" hangingPunct="1">
-      <a:defRPr sz="1200" kern="1200">
-        <a:solidFill>
-          <a:schemeClr val="tx1"/>
-        </a:solidFill>
-        <a:latin typeface="+mn-lt"/>
-        <a:ea typeface="+mn-ea"/>
-        <a:cs typeface="+mn-cs"/>
-      </a:defRPr>
-    </a:lvl4pPr>
-    <a:lvl5pPr marL="1828800" algn="l" defTabSz="914400" rtl="0" eaLnBrk="1" latinLnBrk="1" hangingPunct="1">
-      <a:defRPr sz="1200" kern="1200">
-        <a:solidFill>
-          <a:schemeClr val="tx1"/>
-        </a:solidFill>
-        <a:latin typeface="+mn-lt"/>
-        <a:ea typeface="+mn-ea"/>
-        <a:cs typeface="+mn-cs"/>
-      </a:defRPr>
-    </a:lvl5pPr>
-    <a:lvl6pPr marL="2286000" algn="l" defTabSz="914400" rtl="0" eaLnBrk="1" latinLnBrk="1" hangingPunct="1">
-      <a:defRPr sz="1200" kern="1200">
-        <a:solidFill>
-          <a:schemeClr val="tx1"/>
-        </a:solidFill>
-        <a:latin typeface="+mn-lt"/>
-        <a:ea typeface="+mn-ea"/>
-        <a:cs typeface="+mn-cs"/>
-      </a:defRPr>
-    </a:lvl6pPr>
-    <a:lvl7pPr marL="2743200" algn="l" defTabSz="914400" rtl="0" eaLnBrk="1" latinLnBrk="1" hangingPunct="1">
-      <a:defRPr sz="1200" kern="1200">
-        <a:solidFill>
-          <a:schemeClr val="tx1"/>
-        </a:solidFill>
-        <a:latin typeface="+mn-lt"/>
-        <a:ea typeface="+mn-ea"/>
-        <a:cs typeface="+mn-cs"/>
-      </a:defRPr>
-    </a:lvl7pPr>
-    <a:lvl8pPr marL="3200400" algn="l" defTabSz="914400" rtl="0" eaLnBrk="1" latinLnBrk="1" hangingPunct="1">
-      <a:defRPr sz="1200" kern="1200">
-        <a:solidFill>
-          <a:schemeClr val="tx1"/>
-        </a:solidFill>
-        <a:latin typeface="+mn-lt"/>
-        <a:ea typeface="+mn-ea"/>
-        <a:cs typeface="+mn-cs"/>
-      </a:defRPr>
-    </a:lvl8pPr>
-    <a:lvl9pPr marL="3657600" algn="l" defTabSz="914400" rtl="0" eaLnBrk="1" latinLnBrk="1" hangingPunct="1">
-      <a:defRPr sz="1200" kern="1200">
-        <a:solidFill>
-          <a:schemeClr val="tx1"/>
-        </a:solidFill>
-        <a:latin typeface="+mn-lt"/>
-        <a:ea typeface="+mn-ea"/>
-        <a:cs typeface="+mn-cs"/>
-      </a:defRPr>
-    </a:lvl9pPr>
-  </p:notesStyle>
-</p:notesMaster>
-</file>
-
-<file path=ppt/notesSlides/notesSlide1.xml><?xml version="1.0" encoding="utf-8"?>
-<p:notes xmlns:a="http://schemas.openxmlformats.org/drawingml/2006/main" xmlns:r="http://schemas.openxmlformats.org/officeDocument/2006/relationships" xmlns:p="http://schemas.openxmlformats.org/presentationml/2006/main">
-  <p:cSld>
-    <p:spTree>
-      <p:nvGrpSpPr>
-        <p:cNvPr id="1" name=""/>
-        <p:cNvGrpSpPr/>
-        <p:nvPr/>
-      </p:nvGrpSpPr>
-      <p:grpSpPr>
-        <a:xfrm>
-          <a:off x="0" y="0"/>
-          <a:ext cx="0" cy="0"/>
-          <a:chOff x="0" y="0"/>
-          <a:chExt cx="0" cy="0"/>
-        </a:xfrm>
-      </p:grpSpPr>
-      <p:sp>
-        <p:nvSpPr>
-          <p:cNvPr id="2" name="슬라이드 이미지 개체 틀 1"/>
-          <p:cNvSpPr>
-            <a:spLocks noGrp="1" noRot="1" noChangeAspect="1"/>
-          </p:cNvSpPr>
-          <p:nvPr>
-            <p:ph type="sldImg"/>
-          </p:nvPr>
-        </p:nvSpPr>
-        <p:spPr/>
-      </p:sp>
-      <p:sp>
-        <p:nvSpPr>
-          <p:cNvPr id="3" name="슬라이드 노트 개체 틀 2"/>
-          <p:cNvSpPr>
-            <a:spLocks noGrp="1"/>
-          </p:cNvSpPr>
-          <p:nvPr>
-            <p:ph type="body" idx="1"/>
-          </p:nvPr>
-        </p:nvSpPr>
-        <p:spPr/>
-        <p:txBody>
-          <a:bodyPr/>
-          <a:lstStyle/>
-          <a:p>
-            <a:endParaRPr lang="ko-KR" altLang="en-US"/>
-          </a:p>
-        </p:txBody>
-      </p:sp>
-      <p:sp>
-        <p:nvSpPr>
-          <p:cNvPr id="4" name="슬라이드 번호 개체 틀 3"/>
-          <p:cNvSpPr>
-            <a:spLocks noGrp="1"/>
-          </p:cNvSpPr>
-          <p:nvPr>
-            <p:ph type="sldNum" sz="quarter" idx="5"/>
-          </p:nvPr>
-        </p:nvSpPr>
-        <p:spPr/>
-        <p:txBody>
-          <a:bodyPr/>
-          <a:lstStyle/>
-          <a:p>
-            <a:fld id="{3DB8E99A-A821-4878-BB7E-B74749CD0689}" type="slidenum">
-              <a:rPr lang="ko-KR" altLang="en-US" smtClean="0"/>
-              <a:t>1</a:t>
-            </a:fld>
-            <a:endParaRPr lang="ko-KR" altLang="en-US"/>
-          </a:p>
-        </p:txBody>
-      </p:sp>
-    </p:spTree>
-    <p:extLst>
-      <p:ext uri="{BB962C8B-B14F-4D97-AF65-F5344CB8AC3E}">
-        <p14:creationId xmlns:p14="http://schemas.microsoft.com/office/powerpoint/2010/main" val="3051417444"/>
-      </p:ext>
-    </p:extLst>
-  </p:cSld>
-  <p:clrMapOvr>
-    <a:masterClrMapping/>
-  </p:clrMapOvr>
-</p:notes>
 </file>
 
 <file path=ppt/slideLayouts/slideLayout1.xml><?xml version="1.0" encoding="utf-8"?>
@@ -573,7 +134,7 @@
           <p:cNvPr id="2" name="제목 1">
             <a:extLst>
               <a:ext uri="{FF2B5EF4-FFF2-40B4-BE49-F238E27FC236}">
-                <a16:creationId xmlns:a16="http://schemas.microsoft.com/office/drawing/2014/main" id="{1452A716-02CA-48D4-6997-761BF4DD9B7D}"/>
+                <a16:creationId xmlns:a16="http://schemas.microsoft.com/office/drawing/2014/main" id="{46161300-2714-940A-37BD-0C2CB600ED9F}"/>
               </a:ext>
             </a:extLst>
           </p:cNvPr>
@@ -610,7 +171,7 @@
           <p:cNvPr id="3" name="부제목 2">
             <a:extLst>
               <a:ext uri="{FF2B5EF4-FFF2-40B4-BE49-F238E27FC236}">
-                <a16:creationId xmlns:a16="http://schemas.microsoft.com/office/drawing/2014/main" id="{0E3E6B27-1758-086C-A81B-9A85B3134D8C}"/>
+                <a16:creationId xmlns:a16="http://schemas.microsoft.com/office/drawing/2014/main" id="{688E05E6-0EBC-6151-1995-A59A67A117A1}"/>
               </a:ext>
             </a:extLst>
           </p:cNvPr>
@@ -680,7 +241,7 @@
           <p:cNvPr id="4" name="날짜 개체 틀 3">
             <a:extLst>
               <a:ext uri="{FF2B5EF4-FFF2-40B4-BE49-F238E27FC236}">
-                <a16:creationId xmlns:a16="http://schemas.microsoft.com/office/drawing/2014/main" id="{0AA52008-BD30-ACF3-3BD3-A1463A45FC6B}"/>
+                <a16:creationId xmlns:a16="http://schemas.microsoft.com/office/drawing/2014/main" id="{C2928079-40D3-60D9-746E-2D61893F6E71}"/>
               </a:ext>
             </a:extLst>
           </p:cNvPr>
@@ -696,9 +257,9 @@
           <a:bodyPr/>
           <a:lstStyle/>
           <a:p>
-            <a:fld id="{72FE6C3C-2F39-4241-810A-34D4FDFFAE1C}" type="datetimeFigureOut">
+            <a:fld id="{0A0F69B0-41ED-49C5-8B4B-58091D39838E}" type="datetimeFigureOut">
               <a:rPr lang="ko-KR" altLang="en-US" smtClean="0"/>
-              <a:t>2025-11-29 Sat</a:t>
+              <a:t>2026-04-25 Sat</a:t>
             </a:fld>
             <a:endParaRPr lang="ko-KR" altLang="en-US"/>
           </a:p>
@@ -709,7 +270,7 @@
           <p:cNvPr id="5" name="바닥글 개체 틀 4">
             <a:extLst>
               <a:ext uri="{FF2B5EF4-FFF2-40B4-BE49-F238E27FC236}">
-                <a16:creationId xmlns:a16="http://schemas.microsoft.com/office/drawing/2014/main" id="{9B04E679-BE52-3B6E-FB80-5348F0A49693}"/>
+                <a16:creationId xmlns:a16="http://schemas.microsoft.com/office/drawing/2014/main" id="{0DF96387-A59A-4185-11A0-6214954BFE56}"/>
               </a:ext>
             </a:extLst>
           </p:cNvPr>
@@ -734,7 +295,7 @@
           <p:cNvPr id="6" name="슬라이드 번호 개체 틀 5">
             <a:extLst>
               <a:ext uri="{FF2B5EF4-FFF2-40B4-BE49-F238E27FC236}">
-                <a16:creationId xmlns:a16="http://schemas.microsoft.com/office/drawing/2014/main" id="{593F7FF8-CFBC-C044-CA89-C49B63F9102B}"/>
+                <a16:creationId xmlns:a16="http://schemas.microsoft.com/office/drawing/2014/main" id="{D06DD41B-9A09-BA5B-18E3-DA392BC88C97}"/>
               </a:ext>
             </a:extLst>
           </p:cNvPr>
@@ -750,7 +311,7 @@
           <a:bodyPr/>
           <a:lstStyle/>
           <a:p>
-            <a:fld id="{091EFF73-BC0A-4CE3-A41E-769B10041866}" type="slidenum">
+            <a:fld id="{C3D11B8D-0309-44C1-BA8F-7C7378CE1E75}" type="slidenum">
               <a:rPr lang="ko-KR" altLang="en-US" smtClean="0"/>
               <a:t>‹#›</a:t>
             </a:fld>
@@ -760,10 +321,10 @@
       </p:sp>
       <p:cxnSp>
         <p:nvCxnSpPr>
-          <p:cNvPr id="7" name="직선 연결선 6">
-            <a:extLst>
-              <a:ext uri="{FF2B5EF4-FFF2-40B4-BE49-F238E27FC236}">
-                <a16:creationId xmlns:a16="http://schemas.microsoft.com/office/drawing/2014/main" id="{4553D5E0-298C-6AD2-006F-ADA80AA8A7A4}"/>
+          <p:cNvPr id="8" name="직선 연결선 7">
+            <a:extLst>
+              <a:ext uri="{FF2B5EF4-FFF2-40B4-BE49-F238E27FC236}">
+                <a16:creationId xmlns:a16="http://schemas.microsoft.com/office/drawing/2014/main" id="{EE019EA3-99B1-494B-643C-14B6F7CD5676}"/>
               </a:ext>
             </a:extLst>
           </p:cNvPr>
@@ -772,13 +333,17 @@
         </p:nvCxnSpPr>
         <p:spPr>
           <a:xfrm>
-            <a:off x="0" y="365125"/>
+            <a:off x="0" y="442800"/>
             <a:ext cx="12192000" cy="0"/>
           </a:xfrm>
           <a:prstGeom prst="line">
             <a:avLst/>
           </a:prstGeom>
-          <a:ln w="38100"/>
+          <a:ln w="38100">
+            <a:solidFill>
+              <a:srgbClr val="1F4E79"/>
+            </a:solidFill>
+          </a:ln>
         </p:spPr>
         <p:style>
           <a:lnRef idx="1">
@@ -798,7 +363,7 @@
     </p:spTree>
     <p:extLst>
       <p:ext uri="{BB962C8B-B14F-4D97-AF65-F5344CB8AC3E}">
-        <p14:creationId xmlns:p14="http://schemas.microsoft.com/office/powerpoint/2010/main" val="813112701"/>
+        <p14:creationId xmlns:p14="http://schemas.microsoft.com/office/powerpoint/2010/main" val="2170496540"/>
       </p:ext>
     </p:extLst>
   </p:cSld>
@@ -830,7 +395,7 @@
           <p:cNvPr id="2" name="제목 1">
             <a:extLst>
               <a:ext uri="{FF2B5EF4-FFF2-40B4-BE49-F238E27FC236}">
-                <a16:creationId xmlns:a16="http://schemas.microsoft.com/office/drawing/2014/main" id="{8AF7844A-0D66-6159-87D3-665612C3CBE7}"/>
+                <a16:creationId xmlns:a16="http://schemas.microsoft.com/office/drawing/2014/main" id="{80969E96-0E79-03F2-4617-B4EF5A10AE3B}"/>
               </a:ext>
             </a:extLst>
           </p:cNvPr>
@@ -858,7 +423,7 @@
           <p:cNvPr id="3" name="세로 텍스트 개체 틀 2">
             <a:extLst>
               <a:ext uri="{FF2B5EF4-FFF2-40B4-BE49-F238E27FC236}">
-                <a16:creationId xmlns:a16="http://schemas.microsoft.com/office/drawing/2014/main" id="{0B486F89-EA7B-0809-02A8-AD84534E6575}"/>
+                <a16:creationId xmlns:a16="http://schemas.microsoft.com/office/drawing/2014/main" id="{583B157F-3A47-F6DC-8FDF-BFA3ABEDFB66}"/>
               </a:ext>
             </a:extLst>
           </p:cNvPr>
@@ -915,7 +480,7 @@
           <p:cNvPr id="4" name="날짜 개체 틀 3">
             <a:extLst>
               <a:ext uri="{FF2B5EF4-FFF2-40B4-BE49-F238E27FC236}">
-                <a16:creationId xmlns:a16="http://schemas.microsoft.com/office/drawing/2014/main" id="{AD078FD5-9738-BC5C-2CE7-A89FD5D6B239}"/>
+                <a16:creationId xmlns:a16="http://schemas.microsoft.com/office/drawing/2014/main" id="{C2A16233-CD5C-9E27-0D38-59925DA13E00}"/>
               </a:ext>
             </a:extLst>
           </p:cNvPr>
@@ -931,9 +496,9 @@
           <a:bodyPr/>
           <a:lstStyle/>
           <a:p>
-            <a:fld id="{72FE6C3C-2F39-4241-810A-34D4FDFFAE1C}" type="datetimeFigureOut">
+            <a:fld id="{0A0F69B0-41ED-49C5-8B4B-58091D39838E}" type="datetimeFigureOut">
               <a:rPr lang="ko-KR" altLang="en-US" smtClean="0"/>
-              <a:t>2025-11-29 Sat</a:t>
+              <a:t>2026-04-25 Sat</a:t>
             </a:fld>
             <a:endParaRPr lang="ko-KR" altLang="en-US"/>
           </a:p>
@@ -944,7 +509,7 @@
           <p:cNvPr id="5" name="바닥글 개체 틀 4">
             <a:extLst>
               <a:ext uri="{FF2B5EF4-FFF2-40B4-BE49-F238E27FC236}">
-                <a16:creationId xmlns:a16="http://schemas.microsoft.com/office/drawing/2014/main" id="{FAC66D91-E0CA-2913-4F0D-52A485A21199}"/>
+                <a16:creationId xmlns:a16="http://schemas.microsoft.com/office/drawing/2014/main" id="{105F64A1-8374-21BD-91C6-3ECA40B6B80B}"/>
               </a:ext>
             </a:extLst>
           </p:cNvPr>
@@ -969,7 +534,7 @@
           <p:cNvPr id="6" name="슬라이드 번호 개체 틀 5">
             <a:extLst>
               <a:ext uri="{FF2B5EF4-FFF2-40B4-BE49-F238E27FC236}">
-                <a16:creationId xmlns:a16="http://schemas.microsoft.com/office/drawing/2014/main" id="{F683D936-8513-A749-DD07-FB74B870B376}"/>
+                <a16:creationId xmlns:a16="http://schemas.microsoft.com/office/drawing/2014/main" id="{1BF1018E-A124-7FA3-1D36-7E48013EE7F0}"/>
               </a:ext>
             </a:extLst>
           </p:cNvPr>
@@ -985,7 +550,7 @@
           <a:bodyPr/>
           <a:lstStyle/>
           <a:p>
-            <a:fld id="{091EFF73-BC0A-4CE3-A41E-769B10041866}" type="slidenum">
+            <a:fld id="{C3D11B8D-0309-44C1-BA8F-7C7378CE1E75}" type="slidenum">
               <a:rPr lang="ko-KR" altLang="en-US" smtClean="0"/>
               <a:t>‹#›</a:t>
             </a:fld>
@@ -996,7 +561,7 @@
     </p:spTree>
     <p:extLst>
       <p:ext uri="{BB962C8B-B14F-4D97-AF65-F5344CB8AC3E}">
-        <p14:creationId xmlns:p14="http://schemas.microsoft.com/office/powerpoint/2010/main" val="500581095"/>
+        <p14:creationId xmlns:p14="http://schemas.microsoft.com/office/powerpoint/2010/main" val="1385185557"/>
       </p:ext>
     </p:extLst>
   </p:cSld>
@@ -1028,7 +593,7 @@
           <p:cNvPr id="2" name="세로 제목 1">
             <a:extLst>
               <a:ext uri="{FF2B5EF4-FFF2-40B4-BE49-F238E27FC236}">
-                <a16:creationId xmlns:a16="http://schemas.microsoft.com/office/drawing/2014/main" id="{2374ED23-7AB2-11C4-F5E7-CDFF9531115E}"/>
+                <a16:creationId xmlns:a16="http://schemas.microsoft.com/office/drawing/2014/main" id="{D103545F-45EC-B980-CD06-74C0F69F0372}"/>
               </a:ext>
             </a:extLst>
           </p:cNvPr>
@@ -1061,7 +626,7 @@
           <p:cNvPr id="3" name="세로 텍스트 개체 틀 2">
             <a:extLst>
               <a:ext uri="{FF2B5EF4-FFF2-40B4-BE49-F238E27FC236}">
-                <a16:creationId xmlns:a16="http://schemas.microsoft.com/office/drawing/2014/main" id="{C55912FD-8392-4219-122F-091C84257907}"/>
+                <a16:creationId xmlns:a16="http://schemas.microsoft.com/office/drawing/2014/main" id="{46436FD8-4F4A-416F-035E-CCA9609D5495}"/>
               </a:ext>
             </a:extLst>
           </p:cNvPr>
@@ -1123,7 +688,7 @@
           <p:cNvPr id="4" name="날짜 개체 틀 3">
             <a:extLst>
               <a:ext uri="{FF2B5EF4-FFF2-40B4-BE49-F238E27FC236}">
-                <a16:creationId xmlns:a16="http://schemas.microsoft.com/office/drawing/2014/main" id="{54358ACC-D4B4-CFAA-F399-D643996EA945}"/>
+                <a16:creationId xmlns:a16="http://schemas.microsoft.com/office/drawing/2014/main" id="{33414375-7A83-F897-BEFA-60F1C033AF00}"/>
               </a:ext>
             </a:extLst>
           </p:cNvPr>
@@ -1139,9 +704,9 @@
           <a:bodyPr/>
           <a:lstStyle/>
           <a:p>
-            <a:fld id="{72FE6C3C-2F39-4241-810A-34D4FDFFAE1C}" type="datetimeFigureOut">
+            <a:fld id="{0A0F69B0-41ED-49C5-8B4B-58091D39838E}" type="datetimeFigureOut">
               <a:rPr lang="ko-KR" altLang="en-US" smtClean="0"/>
-              <a:t>2025-11-29 Sat</a:t>
+              <a:t>2026-04-25 Sat</a:t>
             </a:fld>
             <a:endParaRPr lang="ko-KR" altLang="en-US"/>
           </a:p>
@@ -1152,7 +717,7 @@
           <p:cNvPr id="5" name="바닥글 개체 틀 4">
             <a:extLst>
               <a:ext uri="{FF2B5EF4-FFF2-40B4-BE49-F238E27FC236}">
-                <a16:creationId xmlns:a16="http://schemas.microsoft.com/office/drawing/2014/main" id="{5256352B-FC71-34A1-3349-32B44952D256}"/>
+                <a16:creationId xmlns:a16="http://schemas.microsoft.com/office/drawing/2014/main" id="{E3AFAB1A-52AA-E4E6-361E-A8091B835CC0}"/>
               </a:ext>
             </a:extLst>
           </p:cNvPr>
@@ -1177,7 +742,7 @@
           <p:cNvPr id="6" name="슬라이드 번호 개체 틀 5">
             <a:extLst>
               <a:ext uri="{FF2B5EF4-FFF2-40B4-BE49-F238E27FC236}">
-                <a16:creationId xmlns:a16="http://schemas.microsoft.com/office/drawing/2014/main" id="{1730B4F8-22B5-EB3E-5F18-1F5E3A166539}"/>
+                <a16:creationId xmlns:a16="http://schemas.microsoft.com/office/drawing/2014/main" id="{C7FE5C2C-6E5D-030A-A34F-5CF929994AD9}"/>
               </a:ext>
             </a:extLst>
           </p:cNvPr>
@@ -1193,7 +758,7 @@
           <a:bodyPr/>
           <a:lstStyle/>
           <a:p>
-            <a:fld id="{091EFF73-BC0A-4CE3-A41E-769B10041866}" type="slidenum">
+            <a:fld id="{C3D11B8D-0309-44C1-BA8F-7C7378CE1E75}" type="slidenum">
               <a:rPr lang="ko-KR" altLang="en-US" smtClean="0"/>
               <a:t>‹#›</a:t>
             </a:fld>
@@ -1204,7 +769,7 @@
     </p:spTree>
     <p:extLst>
       <p:ext uri="{BB962C8B-B14F-4D97-AF65-F5344CB8AC3E}">
-        <p14:creationId xmlns:p14="http://schemas.microsoft.com/office/powerpoint/2010/main" val="2586375466"/>
+        <p14:creationId xmlns:p14="http://schemas.microsoft.com/office/powerpoint/2010/main" val="190777314"/>
       </p:ext>
     </p:extLst>
   </p:cSld>
@@ -1236,7 +801,7 @@
           <p:cNvPr id="2" name="제목 1">
             <a:extLst>
               <a:ext uri="{FF2B5EF4-FFF2-40B4-BE49-F238E27FC236}">
-                <a16:creationId xmlns:a16="http://schemas.microsoft.com/office/drawing/2014/main" id="{FA9C13F2-56AC-3D10-A20D-9A5463114686}"/>
+                <a16:creationId xmlns:a16="http://schemas.microsoft.com/office/drawing/2014/main" id="{CF809DCE-F722-19E1-C5C7-0D6D52725F48}"/>
               </a:ext>
             </a:extLst>
           </p:cNvPr>
@@ -1264,7 +829,7 @@
           <p:cNvPr id="3" name="내용 개체 틀 2">
             <a:extLst>
               <a:ext uri="{FF2B5EF4-FFF2-40B4-BE49-F238E27FC236}">
-                <a16:creationId xmlns:a16="http://schemas.microsoft.com/office/drawing/2014/main" id="{5E83FAA6-20A9-3115-CAAB-8CCE44CCBD42}"/>
+                <a16:creationId xmlns:a16="http://schemas.microsoft.com/office/drawing/2014/main" id="{490273A6-4FB6-FD5F-C339-25A11CF2A635}"/>
               </a:ext>
             </a:extLst>
           </p:cNvPr>
@@ -1321,7 +886,7 @@
           <p:cNvPr id="4" name="날짜 개체 틀 3">
             <a:extLst>
               <a:ext uri="{FF2B5EF4-FFF2-40B4-BE49-F238E27FC236}">
-                <a16:creationId xmlns:a16="http://schemas.microsoft.com/office/drawing/2014/main" id="{F3D68272-0B7F-EE99-6780-A9ABEF9072B9}"/>
+                <a16:creationId xmlns:a16="http://schemas.microsoft.com/office/drawing/2014/main" id="{67C8BA50-810B-43FC-8C16-450AE9DBA9F5}"/>
               </a:ext>
             </a:extLst>
           </p:cNvPr>
@@ -1337,9 +902,9 @@
           <a:bodyPr/>
           <a:lstStyle/>
           <a:p>
-            <a:fld id="{72FE6C3C-2F39-4241-810A-34D4FDFFAE1C}" type="datetimeFigureOut">
+            <a:fld id="{0A0F69B0-41ED-49C5-8B4B-58091D39838E}" type="datetimeFigureOut">
               <a:rPr lang="ko-KR" altLang="en-US" smtClean="0"/>
-              <a:t>2025-11-29 Sat</a:t>
+              <a:t>2026-04-25 Sat</a:t>
             </a:fld>
             <a:endParaRPr lang="ko-KR" altLang="en-US"/>
           </a:p>
@@ -1350,7 +915,7 @@
           <p:cNvPr id="5" name="바닥글 개체 틀 4">
             <a:extLst>
               <a:ext uri="{FF2B5EF4-FFF2-40B4-BE49-F238E27FC236}">
-                <a16:creationId xmlns:a16="http://schemas.microsoft.com/office/drawing/2014/main" id="{C6622B59-2186-0616-84CD-EC31ECD6E060}"/>
+                <a16:creationId xmlns:a16="http://schemas.microsoft.com/office/drawing/2014/main" id="{2D31A434-7A38-B472-C512-81389FC4F067}"/>
               </a:ext>
             </a:extLst>
           </p:cNvPr>
@@ -1375,7 +940,7 @@
           <p:cNvPr id="6" name="슬라이드 번호 개체 틀 5">
             <a:extLst>
               <a:ext uri="{FF2B5EF4-FFF2-40B4-BE49-F238E27FC236}">
-                <a16:creationId xmlns:a16="http://schemas.microsoft.com/office/drawing/2014/main" id="{D5242B18-CA0F-43A7-86D0-E4FE86060C46}"/>
+                <a16:creationId xmlns:a16="http://schemas.microsoft.com/office/drawing/2014/main" id="{DE142ECD-D68C-8ECB-D994-8FDF59702AF1}"/>
               </a:ext>
             </a:extLst>
           </p:cNvPr>
@@ -1391,7 +956,7 @@
           <a:bodyPr/>
           <a:lstStyle/>
           <a:p>
-            <a:fld id="{091EFF73-BC0A-4CE3-A41E-769B10041866}" type="slidenum">
+            <a:fld id="{C3D11B8D-0309-44C1-BA8F-7C7378CE1E75}" type="slidenum">
               <a:rPr lang="ko-KR" altLang="en-US" smtClean="0"/>
               <a:t>‹#›</a:t>
             </a:fld>
@@ -1399,47 +964,10 @@
           </a:p>
         </p:txBody>
       </p:sp>
-      <p:cxnSp>
-        <p:nvCxnSpPr>
-          <p:cNvPr id="8" name="직선 연결선 7">
-            <a:extLst>
-              <a:ext uri="{FF2B5EF4-FFF2-40B4-BE49-F238E27FC236}">
-                <a16:creationId xmlns:a16="http://schemas.microsoft.com/office/drawing/2014/main" id="{ED67A912-76E2-A2B2-2888-D6D73893FC27}"/>
-              </a:ext>
-            </a:extLst>
-          </p:cNvPr>
-          <p:cNvCxnSpPr/>
-          <p:nvPr userDrawn="1"/>
-        </p:nvCxnSpPr>
-        <p:spPr>
-          <a:xfrm>
-            <a:off x="0" y="365125"/>
-            <a:ext cx="12192000" cy="0"/>
-          </a:xfrm>
-          <a:prstGeom prst="line">
-            <a:avLst/>
-          </a:prstGeom>
-          <a:ln w="38100"/>
-        </p:spPr>
-        <p:style>
-          <a:lnRef idx="1">
-            <a:schemeClr val="accent1"/>
-          </a:lnRef>
-          <a:fillRef idx="0">
-            <a:schemeClr val="accent1"/>
-          </a:fillRef>
-          <a:effectRef idx="0">
-            <a:schemeClr val="accent1"/>
-          </a:effectRef>
-          <a:fontRef idx="minor">
-            <a:schemeClr val="tx1"/>
-          </a:fontRef>
-        </p:style>
-      </p:cxnSp>
     </p:spTree>
     <p:extLst>
       <p:ext uri="{BB962C8B-B14F-4D97-AF65-F5344CB8AC3E}">
-        <p14:creationId xmlns:p14="http://schemas.microsoft.com/office/powerpoint/2010/main" val="419282616"/>
+        <p14:creationId xmlns:p14="http://schemas.microsoft.com/office/powerpoint/2010/main" val="3810533882"/>
       </p:ext>
     </p:extLst>
   </p:cSld>
@@ -1471,7 +999,7 @@
           <p:cNvPr id="2" name="제목 1">
             <a:extLst>
               <a:ext uri="{FF2B5EF4-FFF2-40B4-BE49-F238E27FC236}">
-                <a16:creationId xmlns:a16="http://schemas.microsoft.com/office/drawing/2014/main" id="{D6C2F1E9-B2F5-664B-574B-2EB24BCAC80E}"/>
+                <a16:creationId xmlns:a16="http://schemas.microsoft.com/office/drawing/2014/main" id="{454483FD-083F-8B6A-9268-C1258537D555}"/>
               </a:ext>
             </a:extLst>
           </p:cNvPr>
@@ -1508,7 +1036,7 @@
           <p:cNvPr id="3" name="텍스트 개체 틀 2">
             <a:extLst>
               <a:ext uri="{FF2B5EF4-FFF2-40B4-BE49-F238E27FC236}">
-                <a16:creationId xmlns:a16="http://schemas.microsoft.com/office/drawing/2014/main" id="{58E0C892-8B7A-C1E2-2A14-D5CA9C036FB5}"/>
+                <a16:creationId xmlns:a16="http://schemas.microsoft.com/office/drawing/2014/main" id="{AE1C4606-9C53-4209-CDD8-173CF944879D}"/>
               </a:ext>
             </a:extLst>
           </p:cNvPr>
@@ -1633,7 +1161,7 @@
           <p:cNvPr id="4" name="날짜 개체 틀 3">
             <a:extLst>
               <a:ext uri="{FF2B5EF4-FFF2-40B4-BE49-F238E27FC236}">
-                <a16:creationId xmlns:a16="http://schemas.microsoft.com/office/drawing/2014/main" id="{1BF0C615-374F-A7D1-A1AD-B34C72497D48}"/>
+                <a16:creationId xmlns:a16="http://schemas.microsoft.com/office/drawing/2014/main" id="{8CDB2680-0DEB-74F3-D148-0D7FD238397E}"/>
               </a:ext>
             </a:extLst>
           </p:cNvPr>
@@ -1649,9 +1177,9 @@
           <a:bodyPr/>
           <a:lstStyle/>
           <a:p>
-            <a:fld id="{72FE6C3C-2F39-4241-810A-34D4FDFFAE1C}" type="datetimeFigureOut">
+            <a:fld id="{0A0F69B0-41ED-49C5-8B4B-58091D39838E}" type="datetimeFigureOut">
               <a:rPr lang="ko-KR" altLang="en-US" smtClean="0"/>
-              <a:t>2025-11-29 Sat</a:t>
+              <a:t>2026-04-25 Sat</a:t>
             </a:fld>
             <a:endParaRPr lang="ko-KR" altLang="en-US"/>
           </a:p>
@@ -1662,7 +1190,7 @@
           <p:cNvPr id="5" name="바닥글 개체 틀 4">
             <a:extLst>
               <a:ext uri="{FF2B5EF4-FFF2-40B4-BE49-F238E27FC236}">
-                <a16:creationId xmlns:a16="http://schemas.microsoft.com/office/drawing/2014/main" id="{AE1E7C45-3E39-8377-E252-B7EE3CE9A324}"/>
+                <a16:creationId xmlns:a16="http://schemas.microsoft.com/office/drawing/2014/main" id="{F7401FFD-A336-7831-3555-04E0982FDBA2}"/>
               </a:ext>
             </a:extLst>
           </p:cNvPr>
@@ -1687,7 +1215,7 @@
           <p:cNvPr id="6" name="슬라이드 번호 개체 틀 5">
             <a:extLst>
               <a:ext uri="{FF2B5EF4-FFF2-40B4-BE49-F238E27FC236}">
-                <a16:creationId xmlns:a16="http://schemas.microsoft.com/office/drawing/2014/main" id="{40043AD3-AB88-9851-C3AA-E4135793C673}"/>
+                <a16:creationId xmlns:a16="http://schemas.microsoft.com/office/drawing/2014/main" id="{901119A6-9F81-E70F-37CC-533140E90129}"/>
               </a:ext>
             </a:extLst>
           </p:cNvPr>
@@ -1703,7 +1231,7 @@
           <a:bodyPr/>
           <a:lstStyle/>
           <a:p>
-            <a:fld id="{091EFF73-BC0A-4CE3-A41E-769B10041866}" type="slidenum">
+            <a:fld id="{C3D11B8D-0309-44C1-BA8F-7C7378CE1E75}" type="slidenum">
               <a:rPr lang="ko-KR" altLang="en-US" smtClean="0"/>
               <a:t>‹#›</a:t>
             </a:fld>
@@ -1714,7 +1242,7 @@
     </p:spTree>
     <p:extLst>
       <p:ext uri="{BB962C8B-B14F-4D97-AF65-F5344CB8AC3E}">
-        <p14:creationId xmlns:p14="http://schemas.microsoft.com/office/powerpoint/2010/main" val="2397183877"/>
+        <p14:creationId xmlns:p14="http://schemas.microsoft.com/office/powerpoint/2010/main" val="4171178196"/>
       </p:ext>
     </p:extLst>
   </p:cSld>
@@ -1746,7 +1274,7 @@
           <p:cNvPr id="2" name="제목 1">
             <a:extLst>
               <a:ext uri="{FF2B5EF4-FFF2-40B4-BE49-F238E27FC236}">
-                <a16:creationId xmlns:a16="http://schemas.microsoft.com/office/drawing/2014/main" id="{A9F0C6D2-83A0-FC7B-B123-0D16F82D688B}"/>
+                <a16:creationId xmlns:a16="http://schemas.microsoft.com/office/drawing/2014/main" id="{E60E2F26-372B-5E64-684E-7E8BF1A71E0C}"/>
               </a:ext>
             </a:extLst>
           </p:cNvPr>
@@ -1774,7 +1302,7 @@
           <p:cNvPr id="3" name="내용 개체 틀 2">
             <a:extLst>
               <a:ext uri="{FF2B5EF4-FFF2-40B4-BE49-F238E27FC236}">
-                <a16:creationId xmlns:a16="http://schemas.microsoft.com/office/drawing/2014/main" id="{38CF8833-E813-5D3A-9958-DF91B86A2957}"/>
+                <a16:creationId xmlns:a16="http://schemas.microsoft.com/office/drawing/2014/main" id="{12F981E3-4387-9BCA-914E-236D18C2834E}"/>
               </a:ext>
             </a:extLst>
           </p:cNvPr>
@@ -1836,7 +1364,7 @@
           <p:cNvPr id="4" name="내용 개체 틀 3">
             <a:extLst>
               <a:ext uri="{FF2B5EF4-FFF2-40B4-BE49-F238E27FC236}">
-                <a16:creationId xmlns:a16="http://schemas.microsoft.com/office/drawing/2014/main" id="{EDCE77FD-14BF-C93C-5103-204A6CBC4C25}"/>
+                <a16:creationId xmlns:a16="http://schemas.microsoft.com/office/drawing/2014/main" id="{D8246088-E6C2-0905-A706-8E58DEEAEA98}"/>
               </a:ext>
             </a:extLst>
           </p:cNvPr>
@@ -1898,7 +1426,7 @@
           <p:cNvPr id="5" name="날짜 개체 틀 4">
             <a:extLst>
               <a:ext uri="{FF2B5EF4-FFF2-40B4-BE49-F238E27FC236}">
-                <a16:creationId xmlns:a16="http://schemas.microsoft.com/office/drawing/2014/main" id="{61BA68DA-1F60-08B8-45AF-B01814DA920A}"/>
+                <a16:creationId xmlns:a16="http://schemas.microsoft.com/office/drawing/2014/main" id="{227237EA-2472-4EDD-7993-6225BDCEDF6D}"/>
               </a:ext>
             </a:extLst>
           </p:cNvPr>
@@ -1914,9 +1442,9 @@
           <a:bodyPr/>
           <a:lstStyle/>
           <a:p>
-            <a:fld id="{72FE6C3C-2F39-4241-810A-34D4FDFFAE1C}" type="datetimeFigureOut">
+            <a:fld id="{0A0F69B0-41ED-49C5-8B4B-58091D39838E}" type="datetimeFigureOut">
               <a:rPr lang="ko-KR" altLang="en-US" smtClean="0"/>
-              <a:t>2025-11-29 Sat</a:t>
+              <a:t>2026-04-25 Sat</a:t>
             </a:fld>
             <a:endParaRPr lang="ko-KR" altLang="en-US"/>
           </a:p>
@@ -1927,7 +1455,7 @@
           <p:cNvPr id="6" name="바닥글 개체 틀 5">
             <a:extLst>
               <a:ext uri="{FF2B5EF4-FFF2-40B4-BE49-F238E27FC236}">
-                <a16:creationId xmlns:a16="http://schemas.microsoft.com/office/drawing/2014/main" id="{F87E2304-40CA-0603-AAF3-FD24C1BB2614}"/>
+                <a16:creationId xmlns:a16="http://schemas.microsoft.com/office/drawing/2014/main" id="{F2DE67DE-C713-FC8F-00BA-068CF4D75692}"/>
               </a:ext>
             </a:extLst>
           </p:cNvPr>
@@ -1952,7 +1480,7 @@
           <p:cNvPr id="7" name="슬라이드 번호 개체 틀 6">
             <a:extLst>
               <a:ext uri="{FF2B5EF4-FFF2-40B4-BE49-F238E27FC236}">
-                <a16:creationId xmlns:a16="http://schemas.microsoft.com/office/drawing/2014/main" id="{12B1E789-9071-EB73-6371-C684066C7BB8}"/>
+                <a16:creationId xmlns:a16="http://schemas.microsoft.com/office/drawing/2014/main" id="{64CEA67E-5680-76DF-86E2-7C579FB2953C}"/>
               </a:ext>
             </a:extLst>
           </p:cNvPr>
@@ -1968,7 +1496,7 @@
           <a:bodyPr/>
           <a:lstStyle/>
           <a:p>
-            <a:fld id="{091EFF73-BC0A-4CE3-A41E-769B10041866}" type="slidenum">
+            <a:fld id="{C3D11B8D-0309-44C1-BA8F-7C7378CE1E75}" type="slidenum">
               <a:rPr lang="ko-KR" altLang="en-US" smtClean="0"/>
               <a:t>‹#›</a:t>
             </a:fld>
@@ -1979,7 +1507,7 @@
     </p:spTree>
     <p:extLst>
       <p:ext uri="{BB962C8B-B14F-4D97-AF65-F5344CB8AC3E}">
-        <p14:creationId xmlns:p14="http://schemas.microsoft.com/office/powerpoint/2010/main" val="1470366572"/>
+        <p14:creationId xmlns:p14="http://schemas.microsoft.com/office/powerpoint/2010/main" val="2275075622"/>
       </p:ext>
     </p:extLst>
   </p:cSld>
@@ -2011,7 +1539,7 @@
           <p:cNvPr id="2" name="제목 1">
             <a:extLst>
               <a:ext uri="{FF2B5EF4-FFF2-40B4-BE49-F238E27FC236}">
-                <a16:creationId xmlns:a16="http://schemas.microsoft.com/office/drawing/2014/main" id="{B1FC480E-C0B4-8B18-69FD-F652D782D41D}"/>
+                <a16:creationId xmlns:a16="http://schemas.microsoft.com/office/drawing/2014/main" id="{22AC7237-CFA9-A9AC-FDD7-87D8ACFBFE54}"/>
               </a:ext>
             </a:extLst>
           </p:cNvPr>
@@ -2044,7 +1572,7 @@
           <p:cNvPr id="3" name="텍스트 개체 틀 2">
             <a:extLst>
               <a:ext uri="{FF2B5EF4-FFF2-40B4-BE49-F238E27FC236}">
-                <a16:creationId xmlns:a16="http://schemas.microsoft.com/office/drawing/2014/main" id="{DF67591F-CD8B-1AF9-5050-62688DABD716}"/>
+                <a16:creationId xmlns:a16="http://schemas.microsoft.com/office/drawing/2014/main" id="{8EACA8E5-7EA0-4CD0-6C71-E4F2B5BA36BA}"/>
               </a:ext>
             </a:extLst>
           </p:cNvPr>
@@ -2115,7 +1643,7 @@
           <p:cNvPr id="4" name="내용 개체 틀 3">
             <a:extLst>
               <a:ext uri="{FF2B5EF4-FFF2-40B4-BE49-F238E27FC236}">
-                <a16:creationId xmlns:a16="http://schemas.microsoft.com/office/drawing/2014/main" id="{4FABF6DC-62CE-2E69-18FC-5086C402A140}"/>
+                <a16:creationId xmlns:a16="http://schemas.microsoft.com/office/drawing/2014/main" id="{C87583DE-1989-735E-7241-9F2F768DF928}"/>
               </a:ext>
             </a:extLst>
           </p:cNvPr>
@@ -2177,7 +1705,7 @@
           <p:cNvPr id="5" name="텍스트 개체 틀 4">
             <a:extLst>
               <a:ext uri="{FF2B5EF4-FFF2-40B4-BE49-F238E27FC236}">
-                <a16:creationId xmlns:a16="http://schemas.microsoft.com/office/drawing/2014/main" id="{A4611928-8836-E6E4-11F2-3870CA8BA95B}"/>
+                <a16:creationId xmlns:a16="http://schemas.microsoft.com/office/drawing/2014/main" id="{2DC685E7-E77D-18D4-423E-E7D73FAC0E76}"/>
               </a:ext>
             </a:extLst>
           </p:cNvPr>
@@ -2248,7 +1776,7 @@
           <p:cNvPr id="6" name="내용 개체 틀 5">
             <a:extLst>
               <a:ext uri="{FF2B5EF4-FFF2-40B4-BE49-F238E27FC236}">
-                <a16:creationId xmlns:a16="http://schemas.microsoft.com/office/drawing/2014/main" id="{FA47597A-D6F2-5B87-7394-D0B8EEB1E70E}"/>
+                <a16:creationId xmlns:a16="http://schemas.microsoft.com/office/drawing/2014/main" id="{141CE51F-1F7F-88A5-F5A3-48558EDE837D}"/>
               </a:ext>
             </a:extLst>
           </p:cNvPr>
@@ -2310,7 +1838,7 @@
           <p:cNvPr id="7" name="날짜 개체 틀 6">
             <a:extLst>
               <a:ext uri="{FF2B5EF4-FFF2-40B4-BE49-F238E27FC236}">
-                <a16:creationId xmlns:a16="http://schemas.microsoft.com/office/drawing/2014/main" id="{06FEC301-2102-68D6-C8BB-E2E2B5D1675E}"/>
+                <a16:creationId xmlns:a16="http://schemas.microsoft.com/office/drawing/2014/main" id="{7744A29E-B479-BD9F-F7F5-8F5894AB1813}"/>
               </a:ext>
             </a:extLst>
           </p:cNvPr>
@@ -2326,9 +1854,9 @@
           <a:bodyPr/>
           <a:lstStyle/>
           <a:p>
-            <a:fld id="{72FE6C3C-2F39-4241-810A-34D4FDFFAE1C}" type="datetimeFigureOut">
+            <a:fld id="{0A0F69B0-41ED-49C5-8B4B-58091D39838E}" type="datetimeFigureOut">
               <a:rPr lang="ko-KR" altLang="en-US" smtClean="0"/>
-              <a:t>2025-11-29 Sat</a:t>
+              <a:t>2026-04-25 Sat</a:t>
             </a:fld>
             <a:endParaRPr lang="ko-KR" altLang="en-US"/>
           </a:p>
@@ -2339,7 +1867,7 @@
           <p:cNvPr id="8" name="바닥글 개체 틀 7">
             <a:extLst>
               <a:ext uri="{FF2B5EF4-FFF2-40B4-BE49-F238E27FC236}">
-                <a16:creationId xmlns:a16="http://schemas.microsoft.com/office/drawing/2014/main" id="{C5962603-666B-0C9B-B64B-0CEB6193154B}"/>
+                <a16:creationId xmlns:a16="http://schemas.microsoft.com/office/drawing/2014/main" id="{1409AB04-D0D0-B6B3-DCB1-8AC26DB6890D}"/>
               </a:ext>
             </a:extLst>
           </p:cNvPr>
@@ -2364,7 +1892,7 @@
           <p:cNvPr id="9" name="슬라이드 번호 개체 틀 8">
             <a:extLst>
               <a:ext uri="{FF2B5EF4-FFF2-40B4-BE49-F238E27FC236}">
-                <a16:creationId xmlns:a16="http://schemas.microsoft.com/office/drawing/2014/main" id="{C2E15BED-C66D-E5FC-1E07-C451DE401FC6}"/>
+                <a16:creationId xmlns:a16="http://schemas.microsoft.com/office/drawing/2014/main" id="{6F7628D4-8B76-EE17-D8C8-1B8411FAFDF7}"/>
               </a:ext>
             </a:extLst>
           </p:cNvPr>
@@ -2380,7 +1908,7 @@
           <a:bodyPr/>
           <a:lstStyle/>
           <a:p>
-            <a:fld id="{091EFF73-BC0A-4CE3-A41E-769B10041866}" type="slidenum">
+            <a:fld id="{C3D11B8D-0309-44C1-BA8F-7C7378CE1E75}" type="slidenum">
               <a:rPr lang="ko-KR" altLang="en-US" smtClean="0"/>
               <a:t>‹#›</a:t>
             </a:fld>
@@ -2391,7 +1919,7 @@
     </p:spTree>
     <p:extLst>
       <p:ext uri="{BB962C8B-B14F-4D97-AF65-F5344CB8AC3E}">
-        <p14:creationId xmlns:p14="http://schemas.microsoft.com/office/powerpoint/2010/main" val="1814686647"/>
+        <p14:creationId xmlns:p14="http://schemas.microsoft.com/office/powerpoint/2010/main" val="327674841"/>
       </p:ext>
     </p:extLst>
   </p:cSld>
@@ -2423,7 +1951,7 @@
           <p:cNvPr id="2" name="제목 1">
             <a:extLst>
               <a:ext uri="{FF2B5EF4-FFF2-40B4-BE49-F238E27FC236}">
-                <a16:creationId xmlns:a16="http://schemas.microsoft.com/office/drawing/2014/main" id="{66B678AC-A230-9B9F-9AF7-A48D0BDE69E1}"/>
+                <a16:creationId xmlns:a16="http://schemas.microsoft.com/office/drawing/2014/main" id="{EF0A7E0C-C482-A2F6-BADC-7198DBFFCDF6}"/>
               </a:ext>
             </a:extLst>
           </p:cNvPr>
@@ -2451,7 +1979,7 @@
           <p:cNvPr id="3" name="날짜 개체 틀 2">
             <a:extLst>
               <a:ext uri="{FF2B5EF4-FFF2-40B4-BE49-F238E27FC236}">
-                <a16:creationId xmlns:a16="http://schemas.microsoft.com/office/drawing/2014/main" id="{7E17CDDA-3CE4-46C2-B224-7F18F451F882}"/>
+                <a16:creationId xmlns:a16="http://schemas.microsoft.com/office/drawing/2014/main" id="{FBD3B41B-A52D-D225-DA3C-2E3C63EAF341}"/>
               </a:ext>
             </a:extLst>
           </p:cNvPr>
@@ -2467,9 +1995,9 @@
           <a:bodyPr/>
           <a:lstStyle/>
           <a:p>
-            <a:fld id="{72FE6C3C-2F39-4241-810A-34D4FDFFAE1C}" type="datetimeFigureOut">
+            <a:fld id="{0A0F69B0-41ED-49C5-8B4B-58091D39838E}" type="datetimeFigureOut">
               <a:rPr lang="ko-KR" altLang="en-US" smtClean="0"/>
-              <a:t>2025-11-29 Sat</a:t>
+              <a:t>2026-04-25 Sat</a:t>
             </a:fld>
             <a:endParaRPr lang="ko-KR" altLang="en-US"/>
           </a:p>
@@ -2480,7 +2008,7 @@
           <p:cNvPr id="4" name="바닥글 개체 틀 3">
             <a:extLst>
               <a:ext uri="{FF2B5EF4-FFF2-40B4-BE49-F238E27FC236}">
-                <a16:creationId xmlns:a16="http://schemas.microsoft.com/office/drawing/2014/main" id="{27BEF992-CF3C-9F6F-70ED-5544B6953E04}"/>
+                <a16:creationId xmlns:a16="http://schemas.microsoft.com/office/drawing/2014/main" id="{6533EB7F-42C1-9A39-3155-0069E51E8F7B}"/>
               </a:ext>
             </a:extLst>
           </p:cNvPr>
@@ -2505,7 +2033,7 @@
           <p:cNvPr id="5" name="슬라이드 번호 개체 틀 4">
             <a:extLst>
               <a:ext uri="{FF2B5EF4-FFF2-40B4-BE49-F238E27FC236}">
-                <a16:creationId xmlns:a16="http://schemas.microsoft.com/office/drawing/2014/main" id="{4AEF67E6-6B50-6DD3-1933-9C272456FF78}"/>
+                <a16:creationId xmlns:a16="http://schemas.microsoft.com/office/drawing/2014/main" id="{4F131C6C-993F-7DFE-8B15-B12EC5DC7C4E}"/>
               </a:ext>
             </a:extLst>
           </p:cNvPr>
@@ -2521,7 +2049,7 @@
           <a:bodyPr/>
           <a:lstStyle/>
           <a:p>
-            <a:fld id="{091EFF73-BC0A-4CE3-A41E-769B10041866}" type="slidenum">
+            <a:fld id="{C3D11B8D-0309-44C1-BA8F-7C7378CE1E75}" type="slidenum">
               <a:rPr lang="ko-KR" altLang="en-US" smtClean="0"/>
               <a:t>‹#›</a:t>
             </a:fld>
@@ -2532,7 +2060,7 @@
     </p:spTree>
     <p:extLst>
       <p:ext uri="{BB962C8B-B14F-4D97-AF65-F5344CB8AC3E}">
-        <p14:creationId xmlns:p14="http://schemas.microsoft.com/office/powerpoint/2010/main" val="2046938200"/>
+        <p14:creationId xmlns:p14="http://schemas.microsoft.com/office/powerpoint/2010/main" val="359185698"/>
       </p:ext>
     </p:extLst>
   </p:cSld>
@@ -2564,7 +2092,7 @@
           <p:cNvPr id="2" name="날짜 개체 틀 1">
             <a:extLst>
               <a:ext uri="{FF2B5EF4-FFF2-40B4-BE49-F238E27FC236}">
-                <a16:creationId xmlns:a16="http://schemas.microsoft.com/office/drawing/2014/main" id="{E3C4432D-AC9C-DB16-5BEB-5C5163C1E441}"/>
+                <a16:creationId xmlns:a16="http://schemas.microsoft.com/office/drawing/2014/main" id="{AFD379D4-66B9-A4FB-E646-16B5E95B3F01}"/>
               </a:ext>
             </a:extLst>
           </p:cNvPr>
@@ -2580,9 +2108,9 @@
           <a:bodyPr/>
           <a:lstStyle/>
           <a:p>
-            <a:fld id="{72FE6C3C-2F39-4241-810A-34D4FDFFAE1C}" type="datetimeFigureOut">
+            <a:fld id="{0A0F69B0-41ED-49C5-8B4B-58091D39838E}" type="datetimeFigureOut">
               <a:rPr lang="ko-KR" altLang="en-US" smtClean="0"/>
-              <a:t>2025-11-29 Sat</a:t>
+              <a:t>2026-04-25 Sat</a:t>
             </a:fld>
             <a:endParaRPr lang="ko-KR" altLang="en-US"/>
           </a:p>
@@ -2593,7 +2121,7 @@
           <p:cNvPr id="3" name="바닥글 개체 틀 2">
             <a:extLst>
               <a:ext uri="{FF2B5EF4-FFF2-40B4-BE49-F238E27FC236}">
-                <a16:creationId xmlns:a16="http://schemas.microsoft.com/office/drawing/2014/main" id="{C80F1EB1-D974-B7A1-9AC6-C1E0B740C4AE}"/>
+                <a16:creationId xmlns:a16="http://schemas.microsoft.com/office/drawing/2014/main" id="{5CBC95B1-813E-3511-6289-7774C0EFD103}"/>
               </a:ext>
             </a:extLst>
           </p:cNvPr>
@@ -2618,7 +2146,7 @@
           <p:cNvPr id="4" name="슬라이드 번호 개체 틀 3">
             <a:extLst>
               <a:ext uri="{FF2B5EF4-FFF2-40B4-BE49-F238E27FC236}">
-                <a16:creationId xmlns:a16="http://schemas.microsoft.com/office/drawing/2014/main" id="{5FA0C2F6-56EF-FD79-EC01-9808044AA9F7}"/>
+                <a16:creationId xmlns:a16="http://schemas.microsoft.com/office/drawing/2014/main" id="{29FCAF8E-53A0-60E8-9B06-B1C8C209F554}"/>
               </a:ext>
             </a:extLst>
           </p:cNvPr>
@@ -2634,7 +2162,7 @@
           <a:bodyPr/>
           <a:lstStyle/>
           <a:p>
-            <a:fld id="{091EFF73-BC0A-4CE3-A41E-769B10041866}" type="slidenum">
+            <a:fld id="{C3D11B8D-0309-44C1-BA8F-7C7378CE1E75}" type="slidenum">
               <a:rPr lang="ko-KR" altLang="en-US" smtClean="0"/>
               <a:t>‹#›</a:t>
             </a:fld>
@@ -2645,7 +2173,7 @@
     </p:spTree>
     <p:extLst>
       <p:ext uri="{BB962C8B-B14F-4D97-AF65-F5344CB8AC3E}">
-        <p14:creationId xmlns:p14="http://schemas.microsoft.com/office/powerpoint/2010/main" val="1668160121"/>
+        <p14:creationId xmlns:p14="http://schemas.microsoft.com/office/powerpoint/2010/main" val="1013750666"/>
       </p:ext>
     </p:extLst>
   </p:cSld>
@@ -2677,7 +2205,7 @@
           <p:cNvPr id="2" name="제목 1">
             <a:extLst>
               <a:ext uri="{FF2B5EF4-FFF2-40B4-BE49-F238E27FC236}">
-                <a16:creationId xmlns:a16="http://schemas.microsoft.com/office/drawing/2014/main" id="{22FC747E-2640-7B0D-78CA-C43D488756B0}"/>
+                <a16:creationId xmlns:a16="http://schemas.microsoft.com/office/drawing/2014/main" id="{2A2A1E33-FE95-2BB5-AC47-AABF39F2B596}"/>
               </a:ext>
             </a:extLst>
           </p:cNvPr>
@@ -2714,7 +2242,7 @@
           <p:cNvPr id="3" name="내용 개체 틀 2">
             <a:extLst>
               <a:ext uri="{FF2B5EF4-FFF2-40B4-BE49-F238E27FC236}">
-                <a16:creationId xmlns:a16="http://schemas.microsoft.com/office/drawing/2014/main" id="{BC2E7BAF-5DD8-A076-DB0D-8502BAA34D25}"/>
+                <a16:creationId xmlns:a16="http://schemas.microsoft.com/office/drawing/2014/main" id="{E2BAB8AA-44E8-0B30-AD8F-D3070CB77E9B}"/>
               </a:ext>
             </a:extLst>
           </p:cNvPr>
@@ -2804,7 +2332,7 @@
           <p:cNvPr id="4" name="텍스트 개체 틀 3">
             <a:extLst>
               <a:ext uri="{FF2B5EF4-FFF2-40B4-BE49-F238E27FC236}">
-                <a16:creationId xmlns:a16="http://schemas.microsoft.com/office/drawing/2014/main" id="{966A710F-797E-2369-21CA-EAEB831AD5A2}"/>
+                <a16:creationId xmlns:a16="http://schemas.microsoft.com/office/drawing/2014/main" id="{B35B0E9F-23B4-8296-4E6B-4F2EFA779747}"/>
               </a:ext>
             </a:extLst>
           </p:cNvPr>
@@ -2875,7 +2403,7 @@
           <p:cNvPr id="5" name="날짜 개체 틀 4">
             <a:extLst>
               <a:ext uri="{FF2B5EF4-FFF2-40B4-BE49-F238E27FC236}">
-                <a16:creationId xmlns:a16="http://schemas.microsoft.com/office/drawing/2014/main" id="{1E005ABF-F607-BBD2-CA5F-AD3465496FA7}"/>
+                <a16:creationId xmlns:a16="http://schemas.microsoft.com/office/drawing/2014/main" id="{754ECF03-CEDA-0633-7D62-9974A08D3084}"/>
               </a:ext>
             </a:extLst>
           </p:cNvPr>
@@ -2891,9 +2419,9 @@
           <a:bodyPr/>
           <a:lstStyle/>
           <a:p>
-            <a:fld id="{72FE6C3C-2F39-4241-810A-34D4FDFFAE1C}" type="datetimeFigureOut">
+            <a:fld id="{0A0F69B0-41ED-49C5-8B4B-58091D39838E}" type="datetimeFigureOut">
               <a:rPr lang="ko-KR" altLang="en-US" smtClean="0"/>
-              <a:t>2025-11-29 Sat</a:t>
+              <a:t>2026-04-25 Sat</a:t>
             </a:fld>
             <a:endParaRPr lang="ko-KR" altLang="en-US"/>
           </a:p>
@@ -2904,7 +2432,7 @@
           <p:cNvPr id="6" name="바닥글 개체 틀 5">
             <a:extLst>
               <a:ext uri="{FF2B5EF4-FFF2-40B4-BE49-F238E27FC236}">
-                <a16:creationId xmlns:a16="http://schemas.microsoft.com/office/drawing/2014/main" id="{95A7540E-9952-F8E8-FAFE-6E859E5CCC0C}"/>
+                <a16:creationId xmlns:a16="http://schemas.microsoft.com/office/drawing/2014/main" id="{4CA678EA-1B35-A1D6-7CC5-911978197C78}"/>
               </a:ext>
             </a:extLst>
           </p:cNvPr>
@@ -2929,7 +2457,7 @@
           <p:cNvPr id="7" name="슬라이드 번호 개체 틀 6">
             <a:extLst>
               <a:ext uri="{FF2B5EF4-FFF2-40B4-BE49-F238E27FC236}">
-                <a16:creationId xmlns:a16="http://schemas.microsoft.com/office/drawing/2014/main" id="{1EF0B22D-8A05-3AB3-5553-ADFF68E3E2D3}"/>
+                <a16:creationId xmlns:a16="http://schemas.microsoft.com/office/drawing/2014/main" id="{A3689977-FD83-247C-E872-215DB19F56B0}"/>
               </a:ext>
             </a:extLst>
           </p:cNvPr>
@@ -2945,7 +2473,7 @@
           <a:bodyPr/>
           <a:lstStyle/>
           <a:p>
-            <a:fld id="{091EFF73-BC0A-4CE3-A41E-769B10041866}" type="slidenum">
+            <a:fld id="{C3D11B8D-0309-44C1-BA8F-7C7378CE1E75}" type="slidenum">
               <a:rPr lang="ko-KR" altLang="en-US" smtClean="0"/>
               <a:t>‹#›</a:t>
             </a:fld>
@@ -2956,7 +2484,7 @@
     </p:spTree>
     <p:extLst>
       <p:ext uri="{BB962C8B-B14F-4D97-AF65-F5344CB8AC3E}">
-        <p14:creationId xmlns:p14="http://schemas.microsoft.com/office/powerpoint/2010/main" val="2006200179"/>
+        <p14:creationId xmlns:p14="http://schemas.microsoft.com/office/powerpoint/2010/main" val="685460784"/>
       </p:ext>
     </p:extLst>
   </p:cSld>
@@ -2988,7 +2516,7 @@
           <p:cNvPr id="2" name="제목 1">
             <a:extLst>
               <a:ext uri="{FF2B5EF4-FFF2-40B4-BE49-F238E27FC236}">
-                <a16:creationId xmlns:a16="http://schemas.microsoft.com/office/drawing/2014/main" id="{7B576DCD-2375-81E7-69B1-BFC1B8E7DCF6}"/>
+                <a16:creationId xmlns:a16="http://schemas.microsoft.com/office/drawing/2014/main" id="{85EB5CEE-8AC3-C8AA-B396-B6E80100D91C}"/>
               </a:ext>
             </a:extLst>
           </p:cNvPr>
@@ -3025,7 +2553,7 @@
           <p:cNvPr id="3" name="그림 개체 틀 2">
             <a:extLst>
               <a:ext uri="{FF2B5EF4-FFF2-40B4-BE49-F238E27FC236}">
-                <a16:creationId xmlns:a16="http://schemas.microsoft.com/office/drawing/2014/main" id="{B555D2D2-6511-4F59-3C76-6F6157A85EB8}"/>
+                <a16:creationId xmlns:a16="http://schemas.microsoft.com/office/drawing/2014/main" id="{5CA3031D-31C8-7308-D4B3-781977F32FC8}"/>
               </a:ext>
             </a:extLst>
           </p:cNvPr>
@@ -3092,7 +2620,7 @@
           <p:cNvPr id="4" name="텍스트 개체 틀 3">
             <a:extLst>
               <a:ext uri="{FF2B5EF4-FFF2-40B4-BE49-F238E27FC236}">
-                <a16:creationId xmlns:a16="http://schemas.microsoft.com/office/drawing/2014/main" id="{144DAD9F-8A18-C041-408F-DD5800E9D7BB}"/>
+                <a16:creationId xmlns:a16="http://schemas.microsoft.com/office/drawing/2014/main" id="{73A44BB1-F40F-663D-6B28-1A31DC71E2F0}"/>
               </a:ext>
             </a:extLst>
           </p:cNvPr>
@@ -3163,7 +2691,7 @@
           <p:cNvPr id="5" name="날짜 개체 틀 4">
             <a:extLst>
               <a:ext uri="{FF2B5EF4-FFF2-40B4-BE49-F238E27FC236}">
-                <a16:creationId xmlns:a16="http://schemas.microsoft.com/office/drawing/2014/main" id="{B75C7C07-3F62-C368-0672-169BDF59C8E2}"/>
+                <a16:creationId xmlns:a16="http://schemas.microsoft.com/office/drawing/2014/main" id="{4620C2C4-D657-A0E2-0C47-B25366D7FB8C}"/>
               </a:ext>
             </a:extLst>
           </p:cNvPr>
@@ -3179,9 +2707,9 @@
           <a:bodyPr/>
           <a:lstStyle/>
           <a:p>
-            <a:fld id="{72FE6C3C-2F39-4241-810A-34D4FDFFAE1C}" type="datetimeFigureOut">
+            <a:fld id="{0A0F69B0-41ED-49C5-8B4B-58091D39838E}" type="datetimeFigureOut">
               <a:rPr lang="ko-KR" altLang="en-US" smtClean="0"/>
-              <a:t>2025-11-29 Sat</a:t>
+              <a:t>2026-04-25 Sat</a:t>
             </a:fld>
             <a:endParaRPr lang="ko-KR" altLang="en-US"/>
           </a:p>
@@ -3192,7 +2720,7 @@
           <p:cNvPr id="6" name="바닥글 개체 틀 5">
             <a:extLst>
               <a:ext uri="{FF2B5EF4-FFF2-40B4-BE49-F238E27FC236}">
-                <a16:creationId xmlns:a16="http://schemas.microsoft.com/office/drawing/2014/main" id="{042A0573-6E4D-14DC-7112-AE7FB9863E1E}"/>
+                <a16:creationId xmlns:a16="http://schemas.microsoft.com/office/drawing/2014/main" id="{E3186A47-9786-CED4-98BE-6AC158EE1B23}"/>
               </a:ext>
             </a:extLst>
           </p:cNvPr>
@@ -3217,7 +2745,7 @@
           <p:cNvPr id="7" name="슬라이드 번호 개체 틀 6">
             <a:extLst>
               <a:ext uri="{FF2B5EF4-FFF2-40B4-BE49-F238E27FC236}">
-                <a16:creationId xmlns:a16="http://schemas.microsoft.com/office/drawing/2014/main" id="{35A357F9-1E9D-20AF-F57A-6D753E669910}"/>
+                <a16:creationId xmlns:a16="http://schemas.microsoft.com/office/drawing/2014/main" id="{A6EAFCC1-7E7C-0996-5935-F41D2A99D922}"/>
               </a:ext>
             </a:extLst>
           </p:cNvPr>
@@ -3233,7 +2761,7 @@
           <a:bodyPr/>
           <a:lstStyle/>
           <a:p>
-            <a:fld id="{091EFF73-BC0A-4CE3-A41E-769B10041866}" type="slidenum">
+            <a:fld id="{C3D11B8D-0309-44C1-BA8F-7C7378CE1E75}" type="slidenum">
               <a:rPr lang="ko-KR" altLang="en-US" smtClean="0"/>
               <a:t>‹#›</a:t>
             </a:fld>
@@ -3244,7 +2772,7 @@
     </p:spTree>
     <p:extLst>
       <p:ext uri="{BB962C8B-B14F-4D97-AF65-F5344CB8AC3E}">
-        <p14:creationId xmlns:p14="http://schemas.microsoft.com/office/powerpoint/2010/main" val="3170220824"/>
+        <p14:creationId xmlns:p14="http://schemas.microsoft.com/office/powerpoint/2010/main" val="1356572298"/>
       </p:ext>
     </p:extLst>
   </p:cSld>
@@ -3281,7 +2809,7 @@
           <p:cNvPr id="2" name="제목 개체 틀 1">
             <a:extLst>
               <a:ext uri="{FF2B5EF4-FFF2-40B4-BE49-F238E27FC236}">
-                <a16:creationId xmlns:a16="http://schemas.microsoft.com/office/drawing/2014/main" id="{082C2EBC-CD1C-AC9D-1C10-3C206ECE1E9D}"/>
+                <a16:creationId xmlns:a16="http://schemas.microsoft.com/office/drawing/2014/main" id="{C6B84318-AEA3-D0A0-7583-FD8177EE6F0E}"/>
               </a:ext>
             </a:extLst>
           </p:cNvPr>
@@ -3319,7 +2847,7 @@
           <p:cNvPr id="3" name="텍스트 개체 틀 2">
             <a:extLst>
               <a:ext uri="{FF2B5EF4-FFF2-40B4-BE49-F238E27FC236}">
-                <a16:creationId xmlns:a16="http://schemas.microsoft.com/office/drawing/2014/main" id="{6816D721-DE16-EDF4-56B0-A26C58BADAF8}"/>
+                <a16:creationId xmlns:a16="http://schemas.microsoft.com/office/drawing/2014/main" id="{E93E31A8-EE39-8A9F-EF4A-AE97CCD24410}"/>
               </a:ext>
             </a:extLst>
           </p:cNvPr>
@@ -3386,7 +2914,7 @@
           <p:cNvPr id="4" name="날짜 개체 틀 3">
             <a:extLst>
               <a:ext uri="{FF2B5EF4-FFF2-40B4-BE49-F238E27FC236}">
-                <a16:creationId xmlns:a16="http://schemas.microsoft.com/office/drawing/2014/main" id="{888B6581-34B8-7383-BAF6-79DE0B4B9550}"/>
+                <a16:creationId xmlns:a16="http://schemas.microsoft.com/office/drawing/2014/main" id="{5EDD7ECF-8047-4B7D-8E61-7F39B6B4A66D}"/>
               </a:ext>
             </a:extLst>
           </p:cNvPr>
@@ -3420,9 +2948,9 @@
             </a:lvl1pPr>
           </a:lstStyle>
           <a:p>
-            <a:fld id="{72FE6C3C-2F39-4241-810A-34D4FDFFAE1C}" type="datetimeFigureOut">
+            <a:fld id="{0A0F69B0-41ED-49C5-8B4B-58091D39838E}" type="datetimeFigureOut">
               <a:rPr lang="ko-KR" altLang="en-US" smtClean="0"/>
-              <a:t>2025-11-29 Sat</a:t>
+              <a:t>2026-04-25 Sat</a:t>
             </a:fld>
             <a:endParaRPr lang="ko-KR" altLang="en-US"/>
           </a:p>
@@ -3433,7 +2961,7 @@
           <p:cNvPr id="5" name="바닥글 개체 틀 4">
             <a:extLst>
               <a:ext uri="{FF2B5EF4-FFF2-40B4-BE49-F238E27FC236}">
-                <a16:creationId xmlns:a16="http://schemas.microsoft.com/office/drawing/2014/main" id="{6EDF2FAC-7A3D-6263-90AD-71A79541A222}"/>
+                <a16:creationId xmlns:a16="http://schemas.microsoft.com/office/drawing/2014/main" id="{7250284C-CAFD-5F87-6951-E1C7D0DC5382}"/>
               </a:ext>
             </a:extLst>
           </p:cNvPr>
@@ -3476,7 +3004,7 @@
           <p:cNvPr id="6" name="슬라이드 번호 개체 틀 5">
             <a:extLst>
               <a:ext uri="{FF2B5EF4-FFF2-40B4-BE49-F238E27FC236}">
-                <a16:creationId xmlns:a16="http://schemas.microsoft.com/office/drawing/2014/main" id="{E93331D4-ADE8-7BFC-CB79-86BBA5BC9434}"/>
+                <a16:creationId xmlns:a16="http://schemas.microsoft.com/office/drawing/2014/main" id="{A81EE4F4-AA5C-9700-FF60-8025E5CEA80A}"/>
               </a:ext>
             </a:extLst>
           </p:cNvPr>
@@ -3510,7 +3038,7 @@
             </a:lvl1pPr>
           </a:lstStyle>
           <a:p>
-            <a:fld id="{091EFF73-BC0A-4CE3-A41E-769B10041866}" type="slidenum">
+            <a:fld id="{C3D11B8D-0309-44C1-BA8F-7C7378CE1E75}" type="slidenum">
               <a:rPr lang="ko-KR" altLang="en-US" smtClean="0"/>
               <a:t>‹#›</a:t>
             </a:fld>
@@ -3521,7 +3049,7 @@
     </p:spTree>
     <p:extLst>
       <p:ext uri="{BB962C8B-B14F-4D97-AF65-F5344CB8AC3E}">
-        <p14:creationId xmlns:p14="http://schemas.microsoft.com/office/powerpoint/2010/main" val="1337525795"/>
+        <p14:creationId xmlns:p14="http://schemas.microsoft.com/office/powerpoint/2010/main" val="3131493297"/>
       </p:ext>
     </p:extLst>
   </p:cSld>
@@ -3841,10 +3369,10 @@
       </p:grpSpPr>
       <p:sp>
         <p:nvSpPr>
-          <p:cNvPr id="4" name="TextBox 3">
-            <a:extLst>
-              <a:ext uri="{FF2B5EF4-FFF2-40B4-BE49-F238E27FC236}">
-                <a16:creationId xmlns:a16="http://schemas.microsoft.com/office/drawing/2014/main" id="{63DC37ED-C1FC-2648-6791-4D16A7682E45}"/>
+          <p:cNvPr id="10" name="TextBox 9">
+            <a:extLst>
+              <a:ext uri="{FF2B5EF4-FFF2-40B4-BE49-F238E27FC236}">
+                <a16:creationId xmlns:a16="http://schemas.microsoft.com/office/drawing/2014/main" id="{033B2005-E379-5281-B894-C7A770DE4909}"/>
               </a:ext>
             </a:extLst>
           </p:cNvPr>
@@ -3853,8 +3381,8 @@
         </p:nvSpPr>
         <p:spPr>
           <a:xfrm>
-            <a:off x="0" y="0"/>
-            <a:ext cx="623889" cy="369332"/>
+            <a:off x="65942" y="61545"/>
+            <a:ext cx="914400" cy="369332"/>
           </a:xfrm>
           <a:prstGeom prst="rect">
             <a:avLst/>
@@ -3862,25 +3390,24 @@
           <a:noFill/>
         </p:spPr>
         <p:txBody>
-          <a:bodyPr wrap="none" rtlCol="0">
+          <a:bodyPr wrap="square" rtlCol="0">
             <a:spAutoFit/>
           </a:bodyPr>
           <a:lstStyle/>
           <a:p>
             <a:r>
-              <a:rPr lang="en-US" altLang="ko-KR"/>
-              <a:t>Title</a:t>
-            </a:r>
-            <a:endParaRPr lang="ko-KR" altLang="en-US"/>
-          </a:p>
-        </p:txBody>
-      </p:sp>
-      <p:sp>
-        <p:nvSpPr>
-          <p:cNvPr id="10" name="TextBox 9">
-            <a:extLst>
-              <a:ext uri="{FF2B5EF4-FFF2-40B4-BE49-F238E27FC236}">
-                <a16:creationId xmlns:a16="http://schemas.microsoft.com/office/drawing/2014/main" id="{3FE49783-F0B0-D1AA-F525-F6F0BCE76260}"/>
+              <a:rPr lang="ko-KR" altLang="en-US" b="1"/>
+              <a:t>내용</a:t>
+            </a:r>
+          </a:p>
+        </p:txBody>
+      </p:sp>
+      <p:sp>
+        <p:nvSpPr>
+          <p:cNvPr id="11" name="TextBox 10">
+            <a:extLst>
+              <a:ext uri="{FF2B5EF4-FFF2-40B4-BE49-F238E27FC236}">
+                <a16:creationId xmlns:a16="http://schemas.microsoft.com/office/drawing/2014/main" id="{AA056E76-E16A-F260-3015-9E0501FCEFBE}"/>
               </a:ext>
             </a:extLst>
           </p:cNvPr>
@@ -3889,8 +3416,8 @@
         </p:nvSpPr>
         <p:spPr>
           <a:xfrm>
-            <a:off x="66972" y="545953"/>
-            <a:ext cx="611386" cy="276999"/>
+            <a:off x="153865" y="512883"/>
+            <a:ext cx="914400" cy="276999"/>
           </a:xfrm>
           <a:prstGeom prst="rect">
             <a:avLst/>
@@ -3898,23 +3425,18 @@
           <a:noFill/>
         </p:spPr>
         <p:txBody>
-          <a:bodyPr wrap="none" rtlCol="0">
+          <a:bodyPr wrap="square" rtlCol="0">
             <a:spAutoFit/>
           </a:bodyPr>
           <a:lstStyle/>
           <a:p>
             <a:pPr marL="171450" indent="-171450">
-              <a:spcAft>
-                <a:spcPts val="600"/>
-              </a:spcAft>
               <a:buFont typeface="Arial" panose="020B0604020202020204" pitchFamily="34" charset="0"/>
               <a:buChar char="•"/>
             </a:pPr>
             <a:r>
-              <a:rPr lang="en-US" altLang="ko-KR" sz="1200">
-                <a:latin typeface="+mn-ea"/>
-              </a:rPr>
-              <a:t>test</a:t>
+              <a:rPr lang="ko-KR" altLang="en-US" sz="1200"/>
+              <a:t>내용</a:t>
             </a:r>
           </a:p>
         </p:txBody>
@@ -3922,7 +3444,7 @@
     </p:spTree>
     <p:extLst>
       <p:ext uri="{BB962C8B-B14F-4D97-AF65-F5344CB8AC3E}">
-        <p14:creationId xmlns:p14="http://schemas.microsoft.com/office/powerpoint/2010/main" val="1156747331"/>
+        <p14:creationId xmlns:p14="http://schemas.microsoft.com/office/powerpoint/2010/main" val="80692764"/>
       </p:ext>
     </p:extLst>
   </p:cSld>
@@ -4218,55 +3740,18 @@
     </a:fmtScheme>
   </a:themeElements>
   <a:objectDefaults>
-    <a:spDef>
-      <a:spPr>
-        <a:noFill/>
-        <a:ln w="28575">
-          <a:solidFill>
-            <a:srgbClr val="FF0000"/>
-          </a:solidFill>
-        </a:ln>
-      </a:spPr>
-      <a:bodyPr rtlCol="0" anchor="ctr"/>
-      <a:lstStyle>
-        <a:defPPr algn="ctr">
-          <a:defRPr/>
-        </a:defPPr>
-      </a:lstStyle>
-      <a:style>
-        <a:lnRef idx="2">
-          <a:schemeClr val="accent1">
-            <a:shade val="15000"/>
-          </a:schemeClr>
-        </a:lnRef>
-        <a:fillRef idx="1">
-          <a:schemeClr val="accent1"/>
-        </a:fillRef>
-        <a:effectRef idx="0">
-          <a:schemeClr val="accent1"/>
-        </a:effectRef>
-        <a:fontRef idx="minor">
-          <a:schemeClr val="lt1"/>
-        </a:fontRef>
-      </a:style>
-    </a:spDef>
     <a:txDef>
       <a:spPr>
         <a:noFill/>
       </a:spPr>
-      <a:bodyPr wrap="none" rtlCol="0">
+      <a:bodyPr wrap="square" rtlCol="0">
         <a:spAutoFit/>
       </a:bodyPr>
       <a:lstStyle>
         <a:defPPr marL="171450" indent="-171450" algn="l">
-          <a:spcAft>
-            <a:spcPts val="600"/>
-          </a:spcAft>
           <a:buFont typeface="Arial" panose="020B0604020202020204" pitchFamily="34" charset="0"/>
           <a:buChar char="•"/>
-          <a:defRPr sz="1200" smtClean="0">
-            <a:latin typeface="+mn-ea"/>
-          </a:defRPr>
+          <a:defRPr sz="1200" smtClean="0"/>
         </a:defPPr>
       </a:lstStyle>
     </a:txDef>
@@ -4278,299 +3763,4 @@
     </a:ext>
   </a:extLst>
 </a:theme>
-</file>
-
-<file path=ppt/theme/theme2.xml><?xml version="1.0" encoding="utf-8"?>
-<a:theme xmlns:a="http://schemas.openxmlformats.org/drawingml/2006/main" name="Office 테마">
-  <a:themeElements>
-    <a:clrScheme name="Office">
-      <a:dk1>
-        <a:sysClr val="windowText" lastClr="000000"/>
-      </a:dk1>
-      <a:lt1>
-        <a:sysClr val="window" lastClr="FFFFFF"/>
-      </a:lt1>
-      <a:dk2>
-        <a:srgbClr val="44546A"/>
-      </a:dk2>
-      <a:lt2>
-        <a:srgbClr val="E7E6E6"/>
-      </a:lt2>
-      <a:accent1>
-        <a:srgbClr val="4472C4"/>
-      </a:accent1>
-      <a:accent2>
-        <a:srgbClr val="ED7D31"/>
-      </a:accent2>
-      <a:accent3>
-        <a:srgbClr val="A5A5A5"/>
-      </a:accent3>
-      <a:accent4>
-        <a:srgbClr val="FFC000"/>
-      </a:accent4>
-      <a:accent5>
-        <a:srgbClr val="5B9BD5"/>
-      </a:accent5>
-      <a:accent6>
-        <a:srgbClr val="70AD47"/>
-      </a:accent6>
-      <a:hlink>
-        <a:srgbClr val="0563C1"/>
-      </a:hlink>
-      <a:folHlink>
-        <a:srgbClr val="954F72"/>
-      </a:folHlink>
-    </a:clrScheme>
-    <a:fontScheme name="Office">
-      <a:majorFont>
-        <a:latin typeface="맑은 고딕" panose="020F0302020204030204"/>
-        <a:ea typeface=""/>
-        <a:cs typeface=""/>
-        <a:font script="Jpan" typeface="游ゴシック Light"/>
-        <a:font script="Hang" typeface="맑은 고딕"/>
-        <a:font script="Hans" typeface="等线 Light"/>
-        <a:font script="Hant" typeface="新細明體"/>
-        <a:font script="Arab" typeface="Times New Roman"/>
-        <a:font script="Hebr" typeface="Times New Roman"/>
-        <a:font script="Thai" typeface="Angsana New"/>
-        <a:font script="Ethi" typeface="Nyala"/>
-        <a:font script="Beng" typeface="Vrinda"/>
-        <a:font script="Gujr" typeface="Shruti"/>
-        <a:font script="Khmr" typeface="MoolBoran"/>
-        <a:font script="Knda" typeface="Tunga"/>
-        <a:font script="Guru" typeface="Raavi"/>
-        <a:font script="Cans" typeface="Euphemia"/>
-        <a:font script="Cher" typeface="Plantagenet Cherokee"/>
-        <a:font script="Yiii" typeface="Microsoft Yi Baiti"/>
-        <a:font script="Tibt" typeface="Microsoft Himalaya"/>
-        <a:font script="Thaa" typeface="MV Boli"/>
-        <a:font script="Deva" typeface="Mangal"/>
-        <a:font script="Telu" typeface="Gautami"/>
-        <a:font script="Taml" typeface="Latha"/>
-        <a:font script="Syrc" typeface="Estrangelo Edessa"/>
-        <a:font script="Orya" typeface="Kalinga"/>
-        <a:font script="Mlym" typeface="Kartika"/>
-        <a:font script="Laoo" typeface="DokChampa"/>
-        <a:font script="Sinh" typeface="Iskoola Pota"/>
-        <a:font script="Mong" typeface="Mongolian Baiti"/>
-        <a:font script="Viet" typeface="Times New Roman"/>
-        <a:font script="Uigh" typeface="Microsoft Uighur"/>
-        <a:font script="Geor" typeface="Sylfaen"/>
-        <a:font script="Armn" typeface="Arial"/>
-        <a:font script="Bugi" typeface="Leelawadee UI"/>
-        <a:font script="Bopo" typeface="Microsoft JhengHei"/>
-        <a:font script="Java" typeface="Javanese Text"/>
-        <a:font script="Lisu" typeface="Segoe UI"/>
-        <a:font script="Mymr" typeface="Myanmar Text"/>
-        <a:font script="Nkoo" typeface="Ebrima"/>
-        <a:font script="Olck" typeface="Nirmala UI"/>
-        <a:font script="Osma" typeface="Ebrima"/>
-        <a:font script="Phag" typeface="Phagspa"/>
-        <a:font script="Syrn" typeface="Estrangelo Edessa"/>
-        <a:font script="Syrj" typeface="Estrangelo Edessa"/>
-        <a:font script="Syre" typeface="Estrangelo Edessa"/>
-        <a:font script="Sora" typeface="Nirmala UI"/>
-        <a:font script="Tale" typeface="Microsoft Tai Le"/>
-        <a:font script="Talu" typeface="Microsoft New Tai Lue"/>
-        <a:font script="Tfng" typeface="Ebrima"/>
-      </a:majorFont>
-      <a:minorFont>
-        <a:latin typeface="맑은 고딕" panose="020F0502020204030204"/>
-        <a:ea typeface=""/>
-        <a:cs typeface=""/>
-        <a:font script="Jpan" typeface="游ゴシック"/>
-        <a:font script="Hang" typeface="맑은 고딕"/>
-        <a:font script="Hans" typeface="等线"/>
-        <a:font script="Hant" typeface="新細明體"/>
-        <a:font script="Arab" typeface="Arial"/>
-        <a:font script="Hebr" typeface="Arial"/>
-        <a:font script="Thai" typeface="Cordia New"/>
-        <a:font script="Ethi" typeface="Nyala"/>
-        <a:font script="Beng" typeface="Vrinda"/>
-        <a:font script="Gujr" typeface="Shruti"/>
-        <a:font script="Khmr" typeface="DaunPenh"/>
-        <a:font script="Knda" typeface="Tunga"/>
-        <a:font script="Guru" typeface="Raavi"/>
-        <a:font script="Cans" typeface="Euphemia"/>
-        <a:font script="Cher" typeface="Plantagenet Cherokee"/>
-        <a:font script="Yiii" typeface="Microsoft Yi Baiti"/>
-        <a:font script="Tibt" typeface="Microsoft Himalaya"/>
-        <a:font script="Thaa" typeface="MV Boli"/>
-        <a:font script="Deva" typeface="Mangal"/>
-        <a:font script="Telu" typeface="Gautami"/>
-        <a:font script="Taml" typeface="Latha"/>
-        <a:font script="Syrc" typeface="Estrangelo Edessa"/>
-        <a:font script="Orya" typeface="Kalinga"/>
-        <a:font script="Mlym" typeface="Kartika"/>
-        <a:font script="Laoo" typeface="DokChampa"/>
-        <a:font script="Sinh" typeface="Iskoola Pota"/>
-        <a:font script="Mong" typeface="Mongolian Baiti"/>
-        <a:font script="Viet" typeface="Arial"/>
-        <a:font script="Uigh" typeface="Microsoft Uighur"/>
-        <a:font script="Geor" typeface="Sylfaen"/>
-        <a:font script="Armn" typeface="Arial"/>
-        <a:font script="Bugi" typeface="Leelawadee UI"/>
-        <a:font script="Bopo" typeface="Microsoft JhengHei"/>
-        <a:font script="Java" typeface="Javanese Text"/>
-        <a:font script="Lisu" typeface="Segoe UI"/>
-        <a:font script="Mymr" typeface="Myanmar Text"/>
-        <a:font script="Nkoo" typeface="Ebrima"/>
-        <a:font script="Olck" typeface="Nirmala UI"/>
-        <a:font script="Osma" typeface="Ebrima"/>
-        <a:font script="Phag" typeface="Phagspa"/>
-        <a:font script="Syrn" typeface="Estrangelo Edessa"/>
-        <a:font script="Syrj" typeface="Estrangelo Edessa"/>
-        <a:font script="Syre" typeface="Estrangelo Edessa"/>
-        <a:font script="Sora" typeface="Nirmala UI"/>
-        <a:font script="Tale" typeface="Microsoft Tai Le"/>
-        <a:font script="Talu" typeface="Microsoft New Tai Lue"/>
-        <a:font script="Tfng" typeface="Ebrima"/>
-      </a:minorFont>
-    </a:fontScheme>
-    <a:fmtScheme name="Office">
-      <a:fillStyleLst>
-        <a:solidFill>
-          <a:schemeClr val="phClr"/>
-        </a:solidFill>
-        <a:gradFill rotWithShape="1">
-          <a:gsLst>
-            <a:gs pos="0">
-              <a:schemeClr val="phClr">
-                <a:lumMod val="110000"/>
-                <a:satMod val="105000"/>
-                <a:tint val="67000"/>
-              </a:schemeClr>
-            </a:gs>
-            <a:gs pos="50000">
-              <a:schemeClr val="phClr">
-                <a:lumMod val="105000"/>
-                <a:satMod val="103000"/>
-                <a:tint val="73000"/>
-              </a:schemeClr>
-            </a:gs>
-            <a:gs pos="100000">
-              <a:schemeClr val="phClr">
-                <a:lumMod val="105000"/>
-                <a:satMod val="109000"/>
-                <a:tint val="81000"/>
-              </a:schemeClr>
-            </a:gs>
-          </a:gsLst>
-          <a:lin ang="5400000" scaled="0"/>
-        </a:gradFill>
-        <a:gradFill rotWithShape="1">
-          <a:gsLst>
-            <a:gs pos="0">
-              <a:schemeClr val="phClr">
-                <a:satMod val="103000"/>
-                <a:lumMod val="102000"/>
-                <a:tint val="94000"/>
-              </a:schemeClr>
-            </a:gs>
-            <a:gs pos="50000">
-              <a:schemeClr val="phClr">
-                <a:satMod val="110000"/>
-                <a:lumMod val="100000"/>
-                <a:shade val="100000"/>
-              </a:schemeClr>
-            </a:gs>
-            <a:gs pos="100000">
-              <a:schemeClr val="phClr">
-                <a:lumMod val="99000"/>
-                <a:satMod val="120000"/>
-                <a:shade val="78000"/>
-              </a:schemeClr>
-            </a:gs>
-          </a:gsLst>
-          <a:lin ang="5400000" scaled="0"/>
-        </a:gradFill>
-      </a:fillStyleLst>
-      <a:lnStyleLst>
-        <a:ln w="6350" cap="flat" cmpd="sng" algn="ctr">
-          <a:solidFill>
-            <a:schemeClr val="phClr"/>
-          </a:solidFill>
-          <a:prstDash val="solid"/>
-          <a:miter lim="800000"/>
-        </a:ln>
-        <a:ln w="12700" cap="flat" cmpd="sng" algn="ctr">
-          <a:solidFill>
-            <a:schemeClr val="phClr"/>
-          </a:solidFill>
-          <a:prstDash val="solid"/>
-          <a:miter lim="800000"/>
-        </a:ln>
-        <a:ln w="19050" cap="flat" cmpd="sng" algn="ctr">
-          <a:solidFill>
-            <a:schemeClr val="phClr"/>
-          </a:solidFill>
-          <a:prstDash val="solid"/>
-          <a:miter lim="800000"/>
-        </a:ln>
-      </a:lnStyleLst>
-      <a:effectStyleLst>
-        <a:effectStyle>
-          <a:effectLst/>
-        </a:effectStyle>
-        <a:effectStyle>
-          <a:effectLst/>
-        </a:effectStyle>
-        <a:effectStyle>
-          <a:effectLst>
-            <a:outerShdw blurRad="57150" dist="19050" dir="5400000" algn="ctr" rotWithShape="0">
-              <a:srgbClr val="000000">
-                <a:alpha val="63000"/>
-              </a:srgbClr>
-            </a:outerShdw>
-          </a:effectLst>
-        </a:effectStyle>
-      </a:effectStyleLst>
-      <a:bgFillStyleLst>
-        <a:solidFill>
-          <a:schemeClr val="phClr"/>
-        </a:solidFill>
-        <a:solidFill>
-          <a:schemeClr val="phClr">
-            <a:tint val="95000"/>
-            <a:satMod val="170000"/>
-          </a:schemeClr>
-        </a:solidFill>
-        <a:gradFill rotWithShape="1">
-          <a:gsLst>
-            <a:gs pos="0">
-              <a:schemeClr val="phClr">
-                <a:tint val="93000"/>
-                <a:satMod val="150000"/>
-                <a:shade val="98000"/>
-                <a:lumMod val="102000"/>
-              </a:schemeClr>
-            </a:gs>
-            <a:gs pos="50000">
-              <a:schemeClr val="phClr">
-                <a:tint val="98000"/>
-                <a:satMod val="130000"/>
-                <a:shade val="90000"/>
-                <a:lumMod val="103000"/>
-              </a:schemeClr>
-            </a:gs>
-            <a:gs pos="100000">
-              <a:schemeClr val="phClr">
-                <a:shade val="63000"/>
-                <a:satMod val="120000"/>
-              </a:schemeClr>
-            </a:gs>
-          </a:gsLst>
-          <a:lin ang="5400000" scaled="0"/>
-        </a:gradFill>
-      </a:bgFillStyleLst>
-    </a:fmtScheme>
-  </a:themeElements>
-  <a:objectDefaults/>
-  <a:extraClrSchemeLst/>
-  <a:extLst>
-    <a:ext uri="{05A4C25C-085E-4340-85A3-A5531E510DB2}">
-      <thm15:themeFamily xmlns:thm15="http://schemas.microsoft.com/office/thememl/2012/main" name="Office Theme" id="{62F939B6-93AF-4DB8-9C6B-D6C7DFDC589F}" vid="{4A3C46E8-61CC-4603-A589-7422A47A8E4A}"/>
-    </a:ext>
-  </a:extLst>
-</a:theme>
 </file>
</xml_diff>